<commit_message>
chore(proposta-checklist): refinamentos pos-QA do dossie do gerente
- 03-cartao-a5.svg: corrige texto sobreposto nos quadros "No app"
  (separou "1. Aperte" e botao "ABRIR/ENCERRAR" em elementos distintos
  com x diferente, era a mesma posicao com espacos em branco)
- 04-storyboard-video.svg: move rodape ENGETECNICA do bottom pro topo,
  evitando colisao com labels dos frames 7 e 8 do storyboard
- build.js: paleta do slide 9 (decisao) usa cores luminosas pra
  letras A/B/C/D em vez de tons escuros (contraste sobre navy bg)
- README-proposta.md: adiciona Camada 4 (video WhatsApp) na tabela
  de propostas, cronograma, checklist de aprovacao e anexos
- proposta-checklist.pptx + .pdf: regerados com as correcoes acima
- slide-08.jpg / slide-10.jpg: re-renderizados pos-fix
- PNGs (03-cartao-a5.png, 04-storyboard-video.png): regerados via
  sharp a partir dos SVGs corrigidos

NAO inclui App.js (trabalho anterior, nao desta sessao).

Co-Authored-By: Claude Opus 4.7 <noreply@anthropic.com>
</commit_message>
<xml_diff>
--- a/proposta-checklist/proposta-checklist.pptx
+++ b/proposta-checklist/proposta-checklist.pptx
@@ -14,9 +14,10 @@
     <p:sldId id="262" r:id="rId8"/>
     <p:sldId id="263" r:id="rId9"/>
     <p:sldId id="264" r:id="rId10"/>
+    <p:sldId id="265" r:id="rId11"/>
   </p:sldIdLst>
   <p:notesMasterIdLst>
-    <p:notesMasterId r:id="rId11"/>
+    <p:notesMasterId r:id="rId12"/>
   </p:notesMasterIdLst>
   <p:sldSz cx="12192000" cy="6858000"/>
   <p:notesSz cx="6858000" cy="12192000"/>
@@ -552,6 +553,94 @@
 </p:notes>
 </file>
 
+<file path=ppt/notesSlides/notesSlide10.xml><?xml version="1.0" encoding="utf-8"?>
+<p:notes xmlns:a="http://schemas.openxmlformats.org/drawingml/2006/main" xmlns:r="http://schemas.openxmlformats.org/officeDocument/2006/relationships" xmlns:p="http://schemas.openxmlformats.org/presentationml/2006/main">
+  <p:cSld>
+    <p:spTree>
+      <p:nvGrpSpPr>
+        <p:cNvPr id="1" name=""/>
+        <p:cNvGrpSpPr/>
+        <p:nvPr/>
+      </p:nvGrpSpPr>
+      <p:grpSpPr>
+        <a:xfrm>
+          <a:off x="0" y="0"/>
+          <a:ext cx="0" cy="0"/>
+          <a:chOff x="0" y="0"/>
+          <a:chExt cx="0" cy="0"/>
+        </a:xfrm>
+      </p:grpSpPr>
+      <p:sp>
+        <p:nvSpPr>
+          <p:cNvPr id="2" name="Slide Image Placeholder 1"/>
+          <p:cNvSpPr>
+            <a:spLocks noGrp="1" noRot="1" noChangeAspect="1"/>
+          </p:cNvSpPr>
+          <p:nvPr>
+            <p:ph type="sldImg"/>
+          </p:nvPr>
+        </p:nvSpPr>
+        <p:spPr/>
+      </p:sp>
+      <p:sp>
+        <p:nvSpPr>
+          <p:cNvPr id="3" name="Notes Placeholder 2"/>
+          <p:cNvSpPr>
+            <a:spLocks noGrp="1"/>
+          </p:cNvSpPr>
+          <p:nvPr>
+            <p:ph type="body" idx="1"/>
+          </p:nvPr>
+        </p:nvSpPr>
+        <p:spPr/>
+        <p:txBody>
+          <a:bodyPr/>
+          <a:lstStyle/>
+          <a:p>
+            <a:r>
+              <a:rPr lang="en-US" dirty="0"/>
+              <a:t>Fechamento. Pedir decisão item-a-item. Camadas 1 e 4 podem começar hoje sem custo monetário. Camadas 2 e 3 podem ser aprovadas em separado se houver dúvida sobre custo/escopo. Reforçar o KPI no final: queremos sair de &lt; 60 % para 90 % em 4 semanas. Se aprovar só A (tutorial) e D (vídeo), já temos avanço imediato sem custo.</a:t>
+            </a:r>
+            <a:endParaRPr lang="en-US" dirty="0"/>
+          </a:p>
+        </p:txBody>
+      </p:sp>
+      <p:sp>
+        <p:nvSpPr>
+          <p:cNvPr id="4" name="Slide Number Placeholder 3"/>
+          <p:cNvSpPr>
+            <a:spLocks noGrp="1"/>
+          </p:cNvSpPr>
+          <p:nvPr>
+            <p:ph type="sldNum" sz="quarter" idx="10"/>
+          </p:nvPr>
+        </p:nvSpPr>
+        <p:spPr/>
+        <p:txBody>
+          <a:bodyPr/>
+          <a:lstStyle/>
+          <a:p>
+            <a:fld id="{F7021451-1387-4CA6-816F-3879F97B5CBC}" type="slidenum">
+              <a:rPr lang="en-US"/>
+              <a:t>10</a:t>
+            </a:fld>
+            <a:endParaRPr lang="en-US"/>
+          </a:p>
+        </p:txBody>
+      </p:sp>
+    </p:spTree>
+    <p:extLst>
+      <p:ext uri="{BB962C8B-B14F-4D97-AF65-F5344CB8AC3E}">
+        <p14:creationId xmlns:p14="http://schemas.microsoft.com/office/powerpoint/2010/main" val="1024086991"/>
+      </p:ext>
+    </p:extLst>
+  </p:cSld>
+  <p:clrMapOvr>
+    <a:masterClrMapping/>
+  </p:clrMapOvr>
+</p:notes>
+</file>
+
 <file path=ppt/notesSlides/notesSlide2.xml><?xml version="1.0" encoding="utf-8"?>
 <p:notes xmlns:a="http://schemas.openxmlformats.org/drawingml/2006/main" xmlns:r="http://schemas.openxmlformats.org/officeDocument/2006/relationships" xmlns:p="http://schemas.openxmlformats.org/presentationml/2006/main">
   <p:cSld>
@@ -1126,7 +1215,7 @@
           <a:p>
             <a:r>
               <a:rPr lang="en-US" dirty="0"/>
-              <a:t>Cronograma realista. Nenhuma das ações requer parada de produção. Camada 2 entra na próxima janela de release programada — não acelera deploy.</a:t>
+              <a:t>Camada 4 é o vetor mais eficaz pra equipe leiga. O canal (WhatsApp) já existe. Roteiro completo + storyboard em arquivos separados. Posso ajudar a editar, mas a gravação é melhor com o encarregado — voz dele tem mais autoridade que voz da TI.</a:t>
             </a:r>
             <a:endParaRPr lang="en-US" dirty="0"/>
           </a:p>
@@ -1214,7 +1303,7 @@
           <a:p>
             <a:r>
               <a:rPr lang="en-US" dirty="0"/>
-              <a:t>Fechamento. Pedir decisão item-a-item. Camada 1 pode começar hoje. Camadas 2 e 3 podem ser aprovadas em separado se houver dúvida sobre custo/escopo. Reforçar o KPI no final: queremos sair de &lt; 60 % para 90 % em 4 semanas.</a:t>
+              <a:t>Cronograma realista. Nenhuma das ações requer parada de produção. Camada 2 entra na próxima janela de release programada — não acelera deploy.</a:t>
             </a:r>
             <a:endParaRPr lang="en-US" dirty="0"/>
           </a:p>
@@ -1640,16 +1729,16 @@
         <p:spPr>
           <a:xfrm>
             <a:off x="640080" y="457200"/>
-            <a:ext cx="2743200" cy="457200"/>
-          </a:xfrm>
-          <a:prstGeom prst="rect">
-            <a:avLst/>
-          </a:prstGeom>
-          <a:noFill/>
-          <a:ln/>
-        </p:spPr>
-        <p:txBody>
-          <a:bodyPr wrap="square" rtlCol="0" anchor="ctr"/>
+            <a:ext cx="4572000" cy="457200"/>
+          </a:xfrm>
+          <a:prstGeom prst="rect">
+            <a:avLst/>
+          </a:prstGeom>
+          <a:noFill/>
+          <a:ln/>
+        </p:spPr>
+        <p:txBody>
+          <a:bodyPr wrap="square" lIns="0" tIns="0" rIns="0" bIns="0" rtlCol="0" anchor="ctr"/>
           <a:lstStyle/>
           <a:p>
             <a:pPr indent="0" marL="0">
@@ -1666,31 +1755,6 @@
               </a:rPr>
               <a:t>ENGE</a:t>
             </a:r>
-            <a:endParaRPr lang="en-US" sz="2200" dirty="0"/>
-          </a:p>
-        </p:txBody>
-      </p:sp>
-      <p:sp>
-        <p:nvSpPr>
-          <p:cNvPr id="5" name="Text 3"/>
-          <p:cNvSpPr/>
-          <p:nvPr/>
-        </p:nvSpPr>
-        <p:spPr>
-          <a:xfrm>
-            <a:off x="1508760" y="457200"/>
-            <a:ext cx="2743200" cy="457200"/>
-          </a:xfrm>
-          <a:prstGeom prst="rect">
-            <a:avLst/>
-          </a:prstGeom>
-          <a:noFill/>
-          <a:ln/>
-        </p:spPr>
-        <p:txBody>
-          <a:bodyPr wrap="square" rtlCol="0" anchor="ctr"/>
-          <a:lstStyle/>
-          <a:p>
             <a:pPr indent="0" marL="0">
               <a:buNone/>
             </a:pPr>
@@ -1711,7 +1775,7 @@
       </p:sp>
       <p:sp>
         <p:nvSpPr>
-          <p:cNvPr id="6" name="Text 4"/>
+          <p:cNvPr id="5" name="Text 3"/>
           <p:cNvSpPr/>
           <p:nvPr/>
         </p:nvSpPr>
@@ -1750,7 +1814,7 @@
       </p:sp>
       <p:sp>
         <p:nvSpPr>
-          <p:cNvPr id="7" name="Text 5"/>
+          <p:cNvPr id="6" name="Text 4"/>
           <p:cNvSpPr/>
           <p:nvPr/>
         </p:nvSpPr>
@@ -1789,7 +1853,7 @@
       </p:sp>
       <p:sp>
         <p:nvSpPr>
-          <p:cNvPr id="8" name="Text 6"/>
+          <p:cNvPr id="7" name="Text 5"/>
           <p:cNvSpPr/>
           <p:nvPr/>
         </p:nvSpPr>
@@ -1828,7 +1892,7 @@
       </p:sp>
       <p:sp>
         <p:nvSpPr>
-          <p:cNvPr id="9" name="Shape 7"/>
+          <p:cNvPr id="8" name="Shape 6"/>
           <p:cNvSpPr/>
           <p:nvPr/>
         </p:nvSpPr>
@@ -1848,7 +1912,7 @@
       </p:sp>
       <p:sp>
         <p:nvSpPr>
-          <p:cNvPr id="10" name="Text 8"/>
+          <p:cNvPr id="9" name="Text 7"/>
           <p:cNvSpPr/>
           <p:nvPr/>
         </p:nvSpPr>
@@ -1901,7 +1965,7 @@
       </p:sp>
       <p:sp>
         <p:nvSpPr>
-          <p:cNvPr id="11" name="Text 9"/>
+          <p:cNvPr id="10" name="Text 8"/>
           <p:cNvSpPr/>
           <p:nvPr/>
         </p:nvSpPr>
@@ -1954,7 +2018,7 @@
       </p:sp>
       <p:sp>
         <p:nvSpPr>
-          <p:cNvPr id="12" name="Text 10"/>
+          <p:cNvPr id="11" name="Text 9"/>
           <p:cNvSpPr/>
           <p:nvPr/>
         </p:nvSpPr>
@@ -1986,6 +2050,1088 @@
                 <a:cs typeface="Calibri" pitchFamily="34" charset="-120"/>
               </a:rPr>
               <a:t>23 · jun · 2026</a:t>
+            </a:r>
+            <a:endParaRPr lang="en-US" sz="1100" dirty="0"/>
+          </a:p>
+        </p:txBody>
+      </p:sp>
+    </p:spTree>
+  </p:cSld>
+  <p:clrMapOvr>
+    <a:masterClrMapping/>
+  </p:clrMapOvr>
+</p:sld>
+</file>
+
+<file path=ppt/slides/slide10.xml><?xml version="1.0" encoding="utf-8"?>
+<p:sld xmlns:a="http://schemas.openxmlformats.org/drawingml/2006/main" xmlns:r="http://schemas.openxmlformats.org/officeDocument/2006/relationships" xmlns:p="http://schemas.openxmlformats.org/presentationml/2006/main">
+  <p:cSld name="Slide 10">
+    <p:bg>
+      <p:bgPr>
+        <a:solidFill>
+          <a:srgbClr val="141A35"/>
+        </a:solidFill>
+      </p:bgPr>
+    </p:bg>
+    <p:spTree>
+      <p:nvGrpSpPr>
+        <p:cNvPr id="1" name=""/>
+        <p:cNvGrpSpPr/>
+        <p:nvPr/>
+      </p:nvGrpSpPr>
+      <p:grpSpPr>
+        <a:xfrm>
+          <a:off x="0" y="0"/>
+          <a:ext cx="0" cy="0"/>
+          <a:chOff x="0" y="0"/>
+          <a:chExt cx="0" cy="0"/>
+        </a:xfrm>
+      </p:grpSpPr>
+      <p:sp>
+        <p:nvSpPr>
+          <p:cNvPr id="2" name="Shape 0"/>
+          <p:cNvSpPr/>
+          <p:nvPr/>
+        </p:nvSpPr>
+        <p:spPr>
+          <a:xfrm>
+            <a:off x="-2286000" y="-2286000"/>
+            <a:ext cx="5486400" cy="5486400"/>
+          </a:xfrm>
+          <a:prstGeom prst="ellipse">
+            <a:avLst/>
+          </a:prstGeom>
+          <a:solidFill>
+            <a:srgbClr val="FF7639">
+              <a:alpha val="20000"/>
+            </a:srgbClr>
+          </a:solidFill>
+          <a:ln/>
+        </p:spPr>
+      </p:sp>
+      <p:sp>
+        <p:nvSpPr>
+          <p:cNvPr id="3" name="Shape 1"/>
+          <p:cNvSpPr/>
+          <p:nvPr/>
+        </p:nvSpPr>
+        <p:spPr>
+          <a:xfrm>
+            <a:off x="9144000" y="4114800"/>
+            <a:ext cx="5029200" cy="5029200"/>
+          </a:xfrm>
+          <a:prstGeom prst="ellipse">
+            <a:avLst/>
+          </a:prstGeom>
+          <a:solidFill>
+            <a:srgbClr val="22B07D">
+              <a:alpha val="20000"/>
+            </a:srgbClr>
+          </a:solidFill>
+          <a:ln/>
+        </p:spPr>
+      </p:sp>
+      <p:sp>
+        <p:nvSpPr>
+          <p:cNvPr id="4" name="Text 2"/>
+          <p:cNvSpPr/>
+          <p:nvPr/>
+        </p:nvSpPr>
+        <p:spPr>
+          <a:xfrm>
+            <a:off x="548640" y="365760"/>
+            <a:ext cx="10972800" cy="594360"/>
+          </a:xfrm>
+          <a:prstGeom prst="rect">
+            <a:avLst/>
+          </a:prstGeom>
+          <a:noFill/>
+          <a:ln/>
+        </p:spPr>
+        <p:txBody>
+          <a:bodyPr wrap="square" lIns="0" tIns="0" rIns="0" bIns="0" rtlCol="0" anchor="ctr"/>
+          <a:lstStyle/>
+          <a:p>
+            <a:pPr indent="0" marL="0">
+              <a:buNone/>
+            </a:pPr>
+            <a:r>
+              <a:rPr lang="en-US" sz="3600" b="1" dirty="0">
+                <a:solidFill>
+                  <a:srgbClr val="FFFFFF"/>
+                </a:solidFill>
+                <a:latin typeface="Cambria" pitchFamily="34" charset="0"/>
+                <a:ea typeface="Cambria" pitchFamily="34" charset="-122"/>
+                <a:cs typeface="Cambria" pitchFamily="34" charset="-120"/>
+              </a:rPr>
+              <a:t>Decisão</a:t>
+            </a:r>
+            <a:endParaRPr lang="en-US" sz="3600" dirty="0"/>
+          </a:p>
+        </p:txBody>
+      </p:sp>
+      <p:sp>
+        <p:nvSpPr>
+          <p:cNvPr id="5" name="Text 3"/>
+          <p:cNvSpPr/>
+          <p:nvPr/>
+        </p:nvSpPr>
+        <p:spPr>
+          <a:xfrm>
+            <a:off x="548640" y="960120"/>
+            <a:ext cx="10972800" cy="320040"/>
+          </a:xfrm>
+          <a:prstGeom prst="rect">
+            <a:avLst/>
+          </a:prstGeom>
+          <a:noFill/>
+          <a:ln/>
+        </p:spPr>
+        <p:txBody>
+          <a:bodyPr wrap="square" lIns="0" tIns="0" rIns="0" bIns="0" rtlCol="0" anchor="ctr"/>
+          <a:lstStyle/>
+          <a:p>
+            <a:pPr indent="0" marL="0">
+              <a:buNone/>
+            </a:pPr>
+            <a:r>
+              <a:rPr lang="en-US" sz="1400" dirty="0">
+                <a:solidFill>
+                  <a:srgbClr val="B9C2D6"/>
+                </a:solidFill>
+                <a:latin typeface="Calibri" pitchFamily="34" charset="0"/>
+                <a:ea typeface="Calibri" pitchFamily="34" charset="-122"/>
+                <a:cs typeface="Calibri" pitchFamily="34" charset="-120"/>
+              </a:rPr>
+              <a:t>4 checkboxes — pode aprovar parcialmente, integralmente, ou pedir ajustes.</a:t>
+            </a:r>
+            <a:endParaRPr lang="en-US" sz="1400" dirty="0"/>
+          </a:p>
+        </p:txBody>
+      </p:sp>
+      <p:sp>
+        <p:nvSpPr>
+          <p:cNvPr id="6" name="Shape 4"/>
+          <p:cNvSpPr/>
+          <p:nvPr/>
+        </p:nvSpPr>
+        <p:spPr>
+          <a:xfrm>
+            <a:off x="548640" y="1417320"/>
+            <a:ext cx="11064240" cy="713232"/>
+          </a:xfrm>
+          <a:prstGeom prst="roundRect">
+            <a:avLst>
+              <a:gd name="adj" fmla="val 12821"/>
+            </a:avLst>
+          </a:prstGeom>
+          <a:solidFill>
+            <a:srgbClr val="FFFFFF">
+              <a:alpha val="12000"/>
+            </a:srgbClr>
+          </a:solidFill>
+          <a:ln w="25400">
+            <a:solidFill>
+              <a:srgbClr val="4ADE80"/>
+            </a:solidFill>
+            <a:prstDash val="solid"/>
+          </a:ln>
+        </p:spPr>
+      </p:sp>
+      <p:sp>
+        <p:nvSpPr>
+          <p:cNvPr id="7" name="Shape 5"/>
+          <p:cNvSpPr/>
+          <p:nvPr/>
+        </p:nvSpPr>
+        <p:spPr>
+          <a:xfrm>
+            <a:off x="777240" y="1563624"/>
+            <a:ext cx="420624" cy="420624"/>
+          </a:xfrm>
+          <a:prstGeom prst="roundRect">
+            <a:avLst>
+              <a:gd name="adj" fmla="val 10870"/>
+            </a:avLst>
+          </a:prstGeom>
+          <a:solidFill>
+            <a:srgbClr val="FFFFFF"/>
+          </a:solidFill>
+          <a:ln w="25400">
+            <a:solidFill>
+              <a:srgbClr val="4ADE80"/>
+            </a:solidFill>
+            <a:prstDash val="solid"/>
+          </a:ln>
+        </p:spPr>
+      </p:sp>
+      <p:sp>
+        <p:nvSpPr>
+          <p:cNvPr id="8" name="Text 6"/>
+          <p:cNvSpPr/>
+          <p:nvPr/>
+        </p:nvSpPr>
+        <p:spPr>
+          <a:xfrm>
+            <a:off x="1298448" y="1472184"/>
+            <a:ext cx="411480" cy="594360"/>
+          </a:xfrm>
+          <a:prstGeom prst="rect">
+            <a:avLst/>
+          </a:prstGeom>
+          <a:noFill/>
+          <a:ln/>
+        </p:spPr>
+        <p:txBody>
+          <a:bodyPr wrap="square" lIns="0" tIns="0" rIns="0" bIns="0" rtlCol="0" anchor="ctr"/>
+          <a:lstStyle/>
+          <a:p>
+            <a:pPr algn="ctr" indent="0" marL="0">
+              <a:buNone/>
+            </a:pPr>
+            <a:r>
+              <a:rPr lang="en-US" sz="2400" b="1" dirty="0">
+                <a:solidFill>
+                  <a:srgbClr val="4ADE80"/>
+                </a:solidFill>
+                <a:latin typeface="Cambria" pitchFamily="34" charset="0"/>
+                <a:ea typeface="Cambria" pitchFamily="34" charset="-122"/>
+                <a:cs typeface="Cambria" pitchFamily="34" charset="-120"/>
+              </a:rPr>
+              <a:t>A</a:t>
+            </a:r>
+            <a:endParaRPr lang="en-US" sz="2400" dirty="0"/>
+          </a:p>
+        </p:txBody>
+      </p:sp>
+      <p:sp>
+        <p:nvSpPr>
+          <p:cNvPr id="9" name="Text 7"/>
+          <p:cNvSpPr/>
+          <p:nvPr/>
+        </p:nvSpPr>
+        <p:spPr>
+          <a:xfrm>
+            <a:off x="1783080" y="1490472"/>
+            <a:ext cx="9692640" cy="320040"/>
+          </a:xfrm>
+          <a:prstGeom prst="rect">
+            <a:avLst/>
+          </a:prstGeom>
+          <a:noFill/>
+          <a:ln/>
+        </p:spPr>
+        <p:txBody>
+          <a:bodyPr wrap="square" lIns="0" tIns="0" rIns="0" bIns="0" rtlCol="0" anchor="ctr"/>
+          <a:lstStyle/>
+          <a:p>
+            <a:pPr indent="0" marL="0">
+              <a:buNone/>
+            </a:pPr>
+            <a:r>
+              <a:rPr lang="en-US" sz="1500" b="1" dirty="0">
+                <a:solidFill>
+                  <a:srgbClr val="FFFFFF"/>
+                </a:solidFill>
+                <a:latin typeface="Calibri" pitchFamily="34" charset="0"/>
+                <a:ea typeface="Calibri" pitchFamily="34" charset="-122"/>
+                <a:cs typeface="Calibri" pitchFamily="34" charset="-120"/>
+              </a:rPr>
+              <a:t>Refazer tutorial (Camada 1)</a:t>
+            </a:r>
+            <a:endParaRPr lang="en-US" sz="1500" dirty="0"/>
+          </a:p>
+        </p:txBody>
+      </p:sp>
+      <p:sp>
+        <p:nvSpPr>
+          <p:cNvPr id="10" name="Text 8"/>
+          <p:cNvSpPr/>
+          <p:nvPr/>
+        </p:nvSpPr>
+        <p:spPr>
+          <a:xfrm>
+            <a:off x="1783080" y="1801368"/>
+            <a:ext cx="9692640" cy="292608"/>
+          </a:xfrm>
+          <a:prstGeom prst="rect">
+            <a:avLst/>
+          </a:prstGeom>
+          <a:noFill/>
+          <a:ln/>
+        </p:spPr>
+        <p:txBody>
+          <a:bodyPr wrap="square" lIns="0" tIns="0" rIns="0" bIns="0" rtlCol="0" anchor="ctr"/>
+          <a:lstStyle/>
+          <a:p>
+            <a:pPr indent="0" marL="0">
+              <a:buNone/>
+            </a:pPr>
+            <a:r>
+              <a:rPr lang="en-US" sz="1100" dirty="0">
+                <a:solidFill>
+                  <a:srgbClr val="CAD5E8"/>
+                </a:solidFill>
+                <a:latin typeface="Calibri" pitchFamily="34" charset="0"/>
+                <a:ea typeface="Calibri" pitchFamily="34" charset="-122"/>
+                <a:cs typeface="Calibri" pitchFamily="34" charset="-120"/>
+              </a:rPr>
+              <a:t>~4 h dev · risco zero · faço esta semana</a:t>
+            </a:r>
+            <a:endParaRPr lang="en-US" sz="1100" dirty="0"/>
+          </a:p>
+        </p:txBody>
+      </p:sp>
+      <p:sp>
+        <p:nvSpPr>
+          <p:cNvPr id="11" name="Shape 9"/>
+          <p:cNvSpPr/>
+          <p:nvPr/>
+        </p:nvSpPr>
+        <p:spPr>
+          <a:xfrm>
+            <a:off x="548640" y="2194560"/>
+            <a:ext cx="11064240" cy="713232"/>
+          </a:xfrm>
+          <a:prstGeom prst="roundRect">
+            <a:avLst>
+              <a:gd name="adj" fmla="val 12821"/>
+            </a:avLst>
+          </a:prstGeom>
+          <a:solidFill>
+            <a:srgbClr val="FFFFFF">
+              <a:alpha val="12000"/>
+            </a:srgbClr>
+          </a:solidFill>
+          <a:ln w="25400">
+            <a:solidFill>
+              <a:srgbClr val="FFA940"/>
+            </a:solidFill>
+            <a:prstDash val="solid"/>
+          </a:ln>
+        </p:spPr>
+      </p:sp>
+      <p:sp>
+        <p:nvSpPr>
+          <p:cNvPr id="12" name="Shape 10"/>
+          <p:cNvSpPr/>
+          <p:nvPr/>
+        </p:nvSpPr>
+        <p:spPr>
+          <a:xfrm>
+            <a:off x="777240" y="2340864"/>
+            <a:ext cx="420624" cy="420624"/>
+          </a:xfrm>
+          <a:prstGeom prst="roundRect">
+            <a:avLst>
+              <a:gd name="adj" fmla="val 10870"/>
+            </a:avLst>
+          </a:prstGeom>
+          <a:solidFill>
+            <a:srgbClr val="FFFFFF"/>
+          </a:solidFill>
+          <a:ln w="25400">
+            <a:solidFill>
+              <a:srgbClr val="FFA940"/>
+            </a:solidFill>
+            <a:prstDash val="solid"/>
+          </a:ln>
+        </p:spPr>
+      </p:sp>
+      <p:sp>
+        <p:nvSpPr>
+          <p:cNvPr id="13" name="Text 11"/>
+          <p:cNvSpPr/>
+          <p:nvPr/>
+        </p:nvSpPr>
+        <p:spPr>
+          <a:xfrm>
+            <a:off x="1298448" y="2249424"/>
+            <a:ext cx="411480" cy="594360"/>
+          </a:xfrm>
+          <a:prstGeom prst="rect">
+            <a:avLst/>
+          </a:prstGeom>
+          <a:noFill/>
+          <a:ln/>
+        </p:spPr>
+        <p:txBody>
+          <a:bodyPr wrap="square" lIns="0" tIns="0" rIns="0" bIns="0" rtlCol="0" anchor="ctr"/>
+          <a:lstStyle/>
+          <a:p>
+            <a:pPr algn="ctr" indent="0" marL="0">
+              <a:buNone/>
+            </a:pPr>
+            <a:r>
+              <a:rPr lang="en-US" sz="2400" b="1" dirty="0">
+                <a:solidFill>
+                  <a:srgbClr val="FFA940"/>
+                </a:solidFill>
+                <a:latin typeface="Cambria" pitchFamily="34" charset="0"/>
+                <a:ea typeface="Cambria" pitchFamily="34" charset="-122"/>
+                <a:cs typeface="Cambria" pitchFamily="34" charset="-120"/>
+              </a:rPr>
+              <a:t>B</a:t>
+            </a:r>
+            <a:endParaRPr lang="en-US" sz="2400" dirty="0"/>
+          </a:p>
+        </p:txBody>
+      </p:sp>
+      <p:sp>
+        <p:nvSpPr>
+          <p:cNvPr id="14" name="Text 12"/>
+          <p:cNvSpPr/>
+          <p:nvPr/>
+        </p:nvSpPr>
+        <p:spPr>
+          <a:xfrm>
+            <a:off x="1783080" y="2267712"/>
+            <a:ext cx="9692640" cy="320040"/>
+          </a:xfrm>
+          <a:prstGeom prst="rect">
+            <a:avLst/>
+          </a:prstGeom>
+          <a:noFill/>
+          <a:ln/>
+        </p:spPr>
+        <p:txBody>
+          <a:bodyPr wrap="square" lIns="0" tIns="0" rIns="0" bIns="0" rtlCol="0" anchor="ctr"/>
+          <a:lstStyle/>
+          <a:p>
+            <a:pPr indent="0" marL="0">
+              <a:buNone/>
+            </a:pPr>
+            <a:r>
+              <a:rPr lang="en-US" sz="1500" b="1" dirty="0">
+                <a:solidFill>
+                  <a:srgbClr val="FFFFFF"/>
+                </a:solidFill>
+                <a:latin typeface="Calibri" pitchFamily="34" charset="0"/>
+                <a:ea typeface="Calibri" pitchFamily="34" charset="-122"/>
+                <a:cs typeface="Calibri" pitchFamily="34" charset="-120"/>
+              </a:rPr>
+              <a:t>Redesign do app (Camada 2)</a:t>
+            </a:r>
+            <a:endParaRPr lang="en-US" sz="1500" dirty="0"/>
+          </a:p>
+        </p:txBody>
+      </p:sp>
+      <p:sp>
+        <p:nvSpPr>
+          <p:cNvPr id="15" name="Text 13"/>
+          <p:cNvSpPr/>
+          <p:nvPr/>
+        </p:nvSpPr>
+        <p:spPr>
+          <a:xfrm>
+            <a:off x="1783080" y="2578608"/>
+            <a:ext cx="9692640" cy="292608"/>
+          </a:xfrm>
+          <a:prstGeom prst="rect">
+            <a:avLst/>
+          </a:prstGeom>
+          <a:noFill/>
+          <a:ln/>
+        </p:spPr>
+        <p:txBody>
+          <a:bodyPr wrap="square" lIns="0" tIns="0" rIns="0" bIns="0" rtlCol="0" anchor="ctr"/>
+          <a:lstStyle/>
+          <a:p>
+            <a:pPr indent="0" marL="0">
+              <a:buNone/>
+            </a:pPr>
+            <a:r>
+              <a:rPr lang="en-US" sz="1100" dirty="0">
+                <a:solidFill>
+                  <a:srgbClr val="CAD5E8"/>
+                </a:solidFill>
+                <a:latin typeface="Calibri" pitchFamily="34" charset="0"/>
+                <a:ea typeface="Calibri" pitchFamily="34" charset="-122"/>
+                <a:cs typeface="Calibri" pitchFamily="34" charset="-120"/>
+              </a:rPr>
+              <a:t>~3 dias dev · testar em homologação primeiro</a:t>
+            </a:r>
+            <a:endParaRPr lang="en-US" sz="1100" dirty="0"/>
+          </a:p>
+        </p:txBody>
+      </p:sp>
+      <p:sp>
+        <p:nvSpPr>
+          <p:cNvPr id="16" name="Shape 14"/>
+          <p:cNvSpPr/>
+          <p:nvPr/>
+        </p:nvSpPr>
+        <p:spPr>
+          <a:xfrm>
+            <a:off x="548640" y="2971800"/>
+            <a:ext cx="11064240" cy="713232"/>
+          </a:xfrm>
+          <a:prstGeom prst="roundRect">
+            <a:avLst>
+              <a:gd name="adj" fmla="val 12821"/>
+            </a:avLst>
+          </a:prstGeom>
+          <a:solidFill>
+            <a:srgbClr val="FFFFFF">
+              <a:alpha val="12000"/>
+            </a:srgbClr>
+          </a:solidFill>
+          <a:ln w="25400">
+            <a:solidFill>
+              <a:srgbClr val="60A5FA"/>
+            </a:solidFill>
+            <a:prstDash val="solid"/>
+          </a:ln>
+        </p:spPr>
+      </p:sp>
+      <p:sp>
+        <p:nvSpPr>
+          <p:cNvPr id="17" name="Shape 15"/>
+          <p:cNvSpPr/>
+          <p:nvPr/>
+        </p:nvSpPr>
+        <p:spPr>
+          <a:xfrm>
+            <a:off x="777240" y="3118104"/>
+            <a:ext cx="420624" cy="420624"/>
+          </a:xfrm>
+          <a:prstGeom prst="roundRect">
+            <a:avLst>
+              <a:gd name="adj" fmla="val 10870"/>
+            </a:avLst>
+          </a:prstGeom>
+          <a:solidFill>
+            <a:srgbClr val="FFFFFF"/>
+          </a:solidFill>
+          <a:ln w="25400">
+            <a:solidFill>
+              <a:srgbClr val="60A5FA"/>
+            </a:solidFill>
+            <a:prstDash val="solid"/>
+          </a:ln>
+        </p:spPr>
+      </p:sp>
+      <p:sp>
+        <p:nvSpPr>
+          <p:cNvPr id="18" name="Text 16"/>
+          <p:cNvSpPr/>
+          <p:nvPr/>
+        </p:nvSpPr>
+        <p:spPr>
+          <a:xfrm>
+            <a:off x="1298448" y="3026664"/>
+            <a:ext cx="411480" cy="594360"/>
+          </a:xfrm>
+          <a:prstGeom prst="rect">
+            <a:avLst/>
+          </a:prstGeom>
+          <a:noFill/>
+          <a:ln/>
+        </p:spPr>
+        <p:txBody>
+          <a:bodyPr wrap="square" lIns="0" tIns="0" rIns="0" bIns="0" rtlCol="0" anchor="ctr"/>
+          <a:lstStyle/>
+          <a:p>
+            <a:pPr algn="ctr" indent="0" marL="0">
+              <a:buNone/>
+            </a:pPr>
+            <a:r>
+              <a:rPr lang="en-US" sz="2400" b="1" dirty="0">
+                <a:solidFill>
+                  <a:srgbClr val="60A5FA"/>
+                </a:solidFill>
+                <a:latin typeface="Cambria" pitchFamily="34" charset="0"/>
+                <a:ea typeface="Cambria" pitchFamily="34" charset="-122"/>
+                <a:cs typeface="Cambria" pitchFamily="34" charset="-120"/>
+              </a:rPr>
+              <a:t>C</a:t>
+            </a:r>
+            <a:endParaRPr lang="en-US" sz="2400" dirty="0"/>
+          </a:p>
+        </p:txBody>
+      </p:sp>
+      <p:sp>
+        <p:nvSpPr>
+          <p:cNvPr id="19" name="Text 17"/>
+          <p:cNvSpPr/>
+          <p:nvPr/>
+        </p:nvSpPr>
+        <p:spPr>
+          <a:xfrm>
+            <a:off x="1783080" y="3044952"/>
+            <a:ext cx="9692640" cy="320040"/>
+          </a:xfrm>
+          <a:prstGeom prst="rect">
+            <a:avLst/>
+          </a:prstGeom>
+          <a:noFill/>
+          <a:ln/>
+        </p:spPr>
+        <p:txBody>
+          <a:bodyPr wrap="square" lIns="0" tIns="0" rIns="0" bIns="0" rtlCol="0" anchor="ctr"/>
+          <a:lstStyle/>
+          <a:p>
+            <a:pPr indent="0" marL="0">
+              <a:buNone/>
+            </a:pPr>
+            <a:r>
+              <a:rPr lang="en-US" sz="1500" b="1" dirty="0">
+                <a:solidFill>
+                  <a:srgbClr val="FFFFFF"/>
+                </a:solidFill>
+                <a:latin typeface="Calibri" pitchFamily="34" charset="0"/>
+                <a:ea typeface="Calibri" pitchFamily="34" charset="-122"/>
+                <a:cs typeface="Calibri" pitchFamily="34" charset="-120"/>
+              </a:rPr>
+              <a:t>Cartão A5 impresso (Camada 3)</a:t>
+            </a:r>
+            <a:endParaRPr lang="en-US" sz="1500" dirty="0"/>
+          </a:p>
+        </p:txBody>
+      </p:sp>
+      <p:sp>
+        <p:nvSpPr>
+          <p:cNvPr id="20" name="Text 18"/>
+          <p:cNvSpPr/>
+          <p:nvPr/>
+        </p:nvSpPr>
+        <p:spPr>
+          <a:xfrm>
+            <a:off x="1783080" y="3355848"/>
+            <a:ext cx="9692640" cy="292608"/>
+          </a:xfrm>
+          <a:prstGeom prst="rect">
+            <a:avLst/>
+          </a:prstGeom>
+          <a:noFill/>
+          <a:ln/>
+        </p:spPr>
+        <p:txBody>
+          <a:bodyPr wrap="square" lIns="0" tIns="0" rIns="0" bIns="0" rtlCol="0" anchor="ctr"/>
+          <a:lstStyle/>
+          <a:p>
+            <a:pPr indent="0" marL="0">
+              <a:buNone/>
+            </a:pPr>
+            <a:r>
+              <a:rPr lang="en-US" sz="1100" dirty="0">
+                <a:solidFill>
+                  <a:srgbClr val="CAD5E8"/>
+                </a:solidFill>
+                <a:latin typeface="Calibri" pitchFamily="34" charset="0"/>
+                <a:ea typeface="Calibri" pitchFamily="34" charset="-122"/>
+                <a:cs typeface="Calibri" pitchFamily="34" charset="-120"/>
+              </a:rPr>
+              <a:t>~R$ 5/veículo · uma ordem de impressão</a:t>
+            </a:r>
+            <a:endParaRPr lang="en-US" sz="1100" dirty="0"/>
+          </a:p>
+        </p:txBody>
+      </p:sp>
+      <p:sp>
+        <p:nvSpPr>
+          <p:cNvPr id="21" name="Shape 19"/>
+          <p:cNvSpPr/>
+          <p:nvPr/>
+        </p:nvSpPr>
+        <p:spPr>
+          <a:xfrm>
+            <a:off x="548640" y="3749040"/>
+            <a:ext cx="11064240" cy="713232"/>
+          </a:xfrm>
+          <a:prstGeom prst="roundRect">
+            <a:avLst>
+              <a:gd name="adj" fmla="val 12821"/>
+            </a:avLst>
+          </a:prstGeom>
+          <a:solidFill>
+            <a:srgbClr val="FFFFFF">
+              <a:alpha val="12000"/>
+            </a:srgbClr>
+          </a:solidFill>
+          <a:ln w="25400">
+            <a:solidFill>
+              <a:srgbClr val="F472B6"/>
+            </a:solidFill>
+            <a:prstDash val="solid"/>
+          </a:ln>
+        </p:spPr>
+      </p:sp>
+      <p:sp>
+        <p:nvSpPr>
+          <p:cNvPr id="22" name="Shape 20"/>
+          <p:cNvSpPr/>
+          <p:nvPr/>
+        </p:nvSpPr>
+        <p:spPr>
+          <a:xfrm>
+            <a:off x="777240" y="3895344"/>
+            <a:ext cx="420624" cy="420624"/>
+          </a:xfrm>
+          <a:prstGeom prst="roundRect">
+            <a:avLst>
+              <a:gd name="adj" fmla="val 10870"/>
+            </a:avLst>
+          </a:prstGeom>
+          <a:solidFill>
+            <a:srgbClr val="FFFFFF"/>
+          </a:solidFill>
+          <a:ln w="25400">
+            <a:solidFill>
+              <a:srgbClr val="F472B6"/>
+            </a:solidFill>
+            <a:prstDash val="solid"/>
+          </a:ln>
+        </p:spPr>
+      </p:sp>
+      <p:sp>
+        <p:nvSpPr>
+          <p:cNvPr id="23" name="Text 21"/>
+          <p:cNvSpPr/>
+          <p:nvPr/>
+        </p:nvSpPr>
+        <p:spPr>
+          <a:xfrm>
+            <a:off x="1298448" y="3803904"/>
+            <a:ext cx="411480" cy="594360"/>
+          </a:xfrm>
+          <a:prstGeom prst="rect">
+            <a:avLst/>
+          </a:prstGeom>
+          <a:noFill/>
+          <a:ln/>
+        </p:spPr>
+        <p:txBody>
+          <a:bodyPr wrap="square" lIns="0" tIns="0" rIns="0" bIns="0" rtlCol="0" anchor="ctr"/>
+          <a:lstStyle/>
+          <a:p>
+            <a:pPr algn="ctr" indent="0" marL="0">
+              <a:buNone/>
+            </a:pPr>
+            <a:r>
+              <a:rPr lang="en-US" sz="2400" b="1" dirty="0">
+                <a:solidFill>
+                  <a:srgbClr val="F472B6"/>
+                </a:solidFill>
+                <a:latin typeface="Cambria" pitchFamily="34" charset="0"/>
+                <a:ea typeface="Cambria" pitchFamily="34" charset="-122"/>
+                <a:cs typeface="Cambria" pitchFamily="34" charset="-120"/>
+              </a:rPr>
+              <a:t>D</a:t>
+            </a:r>
+            <a:endParaRPr lang="en-US" sz="2400" dirty="0"/>
+          </a:p>
+        </p:txBody>
+      </p:sp>
+      <p:sp>
+        <p:nvSpPr>
+          <p:cNvPr id="24" name="Text 22"/>
+          <p:cNvSpPr/>
+          <p:nvPr/>
+        </p:nvSpPr>
+        <p:spPr>
+          <a:xfrm>
+            <a:off x="1783080" y="3822192"/>
+            <a:ext cx="9692640" cy="320040"/>
+          </a:xfrm>
+          <a:prstGeom prst="rect">
+            <a:avLst/>
+          </a:prstGeom>
+          <a:noFill/>
+          <a:ln/>
+        </p:spPr>
+        <p:txBody>
+          <a:bodyPr wrap="square" lIns="0" tIns="0" rIns="0" bIns="0" rtlCol="0" anchor="ctr"/>
+          <a:lstStyle/>
+          <a:p>
+            <a:pPr indent="0" marL="0">
+              <a:buNone/>
+            </a:pPr>
+            <a:r>
+              <a:rPr lang="en-US" sz="1500" b="1" dirty="0">
+                <a:solidFill>
+                  <a:srgbClr val="FFFFFF"/>
+                </a:solidFill>
+                <a:latin typeface="Calibri" pitchFamily="34" charset="0"/>
+                <a:ea typeface="Calibri" pitchFamily="34" charset="-122"/>
+                <a:cs typeface="Calibri" pitchFamily="34" charset="-120"/>
+              </a:rPr>
+              <a:t>Vídeo de treinamento WhatsApp (Camada 4)</a:t>
+            </a:r>
+            <a:endParaRPr lang="en-US" sz="1500" dirty="0"/>
+          </a:p>
+        </p:txBody>
+      </p:sp>
+      <p:sp>
+        <p:nvSpPr>
+          <p:cNvPr id="25" name="Text 23"/>
+          <p:cNvSpPr/>
+          <p:nvPr/>
+        </p:nvSpPr>
+        <p:spPr>
+          <a:xfrm>
+            <a:off x="1783080" y="4133088"/>
+            <a:ext cx="9692640" cy="292608"/>
+          </a:xfrm>
+          <a:prstGeom prst="rect">
+            <a:avLst/>
+          </a:prstGeom>
+          <a:noFill/>
+          <a:ln/>
+        </p:spPr>
+        <p:txBody>
+          <a:bodyPr wrap="square" lIns="0" tIns="0" rIns="0" bIns="0" rtlCol="0" anchor="ctr"/>
+          <a:lstStyle/>
+          <a:p>
+            <a:pPr indent="0" marL="0">
+              <a:buNone/>
+            </a:pPr>
+            <a:r>
+              <a:rPr lang="en-US" sz="1100" dirty="0">
+                <a:solidFill>
+                  <a:srgbClr val="CAD5E8"/>
+                </a:solidFill>
+                <a:latin typeface="Calibri" pitchFamily="34" charset="0"/>
+                <a:ea typeface="Calibri" pitchFamily="34" charset="-122"/>
+                <a:cs typeface="Calibri" pitchFamily="34" charset="-120"/>
+              </a:rPr>
+              <a:t>R$ 0 · ~3 h do encarregado · publicado em 1 dia</a:t>
+            </a:r>
+            <a:endParaRPr lang="en-US" sz="1100" dirty="0"/>
+          </a:p>
+        </p:txBody>
+      </p:sp>
+      <p:sp>
+        <p:nvSpPr>
+          <p:cNvPr id="26" name="Shape 24"/>
+          <p:cNvSpPr/>
+          <p:nvPr/>
+        </p:nvSpPr>
+        <p:spPr>
+          <a:xfrm>
+            <a:off x="548640" y="4709160"/>
+            <a:ext cx="11064240" cy="1417320"/>
+          </a:xfrm>
+          <a:prstGeom prst="roundRect">
+            <a:avLst>
+              <a:gd name="adj" fmla="val 7742"/>
+            </a:avLst>
+          </a:prstGeom>
+          <a:solidFill>
+            <a:srgbClr val="1F2A55"/>
+          </a:solidFill>
+          <a:ln w="25400">
+            <a:solidFill>
+              <a:srgbClr val="FF7639"/>
+            </a:solidFill>
+            <a:prstDash val="solid"/>
+          </a:ln>
+        </p:spPr>
+      </p:sp>
+      <p:sp>
+        <p:nvSpPr>
+          <p:cNvPr id="27" name="Text 25"/>
+          <p:cNvSpPr/>
+          <p:nvPr/>
+        </p:nvSpPr>
+        <p:spPr>
+          <a:xfrm>
+            <a:off x="777240" y="4846320"/>
+            <a:ext cx="7315200" cy="320040"/>
+          </a:xfrm>
+          <a:prstGeom prst="rect">
+            <a:avLst/>
+          </a:prstGeom>
+          <a:noFill/>
+          <a:ln/>
+        </p:spPr>
+        <p:txBody>
+          <a:bodyPr wrap="square" lIns="0" tIns="0" rIns="0" bIns="0" rtlCol="0" anchor="ctr"/>
+          <a:lstStyle/>
+          <a:p>
+            <a:pPr indent="0" marL="0">
+              <a:buNone/>
+            </a:pPr>
+            <a:r>
+              <a:rPr lang="en-US" sz="1100" b="1" spc="400" kern="0" dirty="0">
+                <a:solidFill>
+                  <a:srgbClr val="FF7639"/>
+                </a:solidFill>
+                <a:latin typeface="Calibri" pitchFamily="34" charset="0"/>
+                <a:ea typeface="Calibri" pitchFamily="34" charset="-122"/>
+                <a:cs typeface="Calibri" pitchFamily="34" charset="-120"/>
+              </a:rPr>
+              <a:t>KPI sugerido para medir:</a:t>
+            </a:r>
+            <a:endParaRPr lang="en-US" sz="1100" dirty="0"/>
+          </a:p>
+        </p:txBody>
+      </p:sp>
+      <p:sp>
+        <p:nvSpPr>
+          <p:cNvPr id="28" name="Text 26"/>
+          <p:cNvSpPr/>
+          <p:nvPr/>
+        </p:nvSpPr>
+        <p:spPr>
+          <a:xfrm>
+            <a:off x="777240" y="5166360"/>
+            <a:ext cx="7315200" cy="502920"/>
+          </a:xfrm>
+          <a:prstGeom prst="rect">
+            <a:avLst/>
+          </a:prstGeom>
+          <a:noFill/>
+          <a:ln/>
+        </p:spPr>
+        <p:txBody>
+          <a:bodyPr wrap="square" lIns="0" tIns="0" rIns="0" bIns="0" rtlCol="0" anchor="ctr"/>
+          <a:lstStyle/>
+          <a:p>
+            <a:pPr indent="0" marL="0">
+              <a:buNone/>
+            </a:pPr>
+            <a:r>
+              <a:rPr lang="en-US" sz="2000" b="1" dirty="0">
+                <a:solidFill>
+                  <a:srgbClr val="FFFFFF"/>
+                </a:solidFill>
+                <a:latin typeface="Cambria" pitchFamily="34" charset="0"/>
+                <a:ea typeface="Cambria" pitchFamily="34" charset="-122"/>
+                <a:cs typeface="Cambria" pitchFamily="34" charset="-120"/>
+              </a:rPr>
+              <a:t>% de turnos com encerramento no mesmo dia</a:t>
+            </a:r>
+            <a:endParaRPr lang="en-US" sz="2000" dirty="0"/>
+          </a:p>
+        </p:txBody>
+      </p:sp>
+      <p:sp>
+        <p:nvSpPr>
+          <p:cNvPr id="29" name="Text 27"/>
+          <p:cNvSpPr/>
+          <p:nvPr/>
+        </p:nvSpPr>
+        <p:spPr>
+          <a:xfrm>
+            <a:off x="777240" y="5669280"/>
+            <a:ext cx="7315200" cy="365760"/>
+          </a:xfrm>
+          <a:prstGeom prst="rect">
+            <a:avLst/>
+          </a:prstGeom>
+          <a:noFill/>
+          <a:ln/>
+        </p:spPr>
+        <p:txBody>
+          <a:bodyPr wrap="square" lIns="0" tIns="0" rIns="0" bIns="0" rtlCol="0" anchor="ctr"/>
+          <a:lstStyle/>
+          <a:p>
+            <a:pPr indent="0" marL="0">
+              <a:buNone/>
+            </a:pPr>
+            <a:r>
+              <a:rPr lang="en-US" sz="1200" dirty="0">
+                <a:solidFill>
+                  <a:srgbClr val="B9C2D6"/>
+                </a:solidFill>
+                <a:latin typeface="Calibri" pitchFamily="34" charset="0"/>
+                <a:ea typeface="Calibri" pitchFamily="34" charset="-122"/>
+                <a:cs typeface="Calibri" pitchFamily="34" charset="-120"/>
+              </a:rPr>
+              <a:t>Hoje (estimado): &lt; 60 %  →  Meta em 4 semanas: ≥ 90 %</a:t>
+            </a:r>
+            <a:endParaRPr lang="en-US" sz="1200" dirty="0"/>
+          </a:p>
+        </p:txBody>
+      </p:sp>
+      <p:sp>
+        <p:nvSpPr>
+          <p:cNvPr id="30" name="Text 28"/>
+          <p:cNvSpPr/>
+          <p:nvPr/>
+        </p:nvSpPr>
+        <p:spPr>
+          <a:xfrm>
+            <a:off x="8686800" y="4754880"/>
+            <a:ext cx="2743200" cy="1325880"/>
+          </a:xfrm>
+          <a:prstGeom prst="rect">
+            <a:avLst/>
+          </a:prstGeom>
+          <a:noFill/>
+          <a:ln/>
+        </p:spPr>
+        <p:txBody>
+          <a:bodyPr wrap="square" lIns="0" tIns="0" rIns="0" bIns="0" rtlCol="0" anchor="ctr"/>
+          <a:lstStyle/>
+          <a:p>
+            <a:pPr algn="ctr" indent="0" marL="0">
+              <a:buNone/>
+            </a:pPr>
+            <a:r>
+              <a:rPr lang="en-US" sz="7600" b="1" dirty="0">
+                <a:solidFill>
+                  <a:srgbClr val="FF7639"/>
+                </a:solidFill>
+                <a:latin typeface="Cambria" pitchFamily="34" charset="0"/>
+                <a:ea typeface="Cambria" pitchFamily="34" charset="-122"/>
+                <a:cs typeface="Cambria" pitchFamily="34" charset="-120"/>
+              </a:rPr>
+              <a:t>90%</a:t>
+            </a:r>
+            <a:endParaRPr lang="en-US" sz="7600" dirty="0"/>
+          </a:p>
+        </p:txBody>
+      </p:sp>
+      <p:sp>
+        <p:nvSpPr>
+          <p:cNvPr id="31" name="Text 29"/>
+          <p:cNvSpPr/>
+          <p:nvPr/>
+        </p:nvSpPr>
+        <p:spPr>
+          <a:xfrm>
+            <a:off x="548640" y="6355080"/>
+            <a:ext cx="11064240" cy="274320"/>
+          </a:xfrm>
+          <a:prstGeom prst="rect">
+            <a:avLst/>
+          </a:prstGeom>
+          <a:noFill/>
+          <a:ln/>
+        </p:spPr>
+        <p:txBody>
+          <a:bodyPr wrap="square" lIns="0" tIns="0" rIns="0" bIns="0" rtlCol="0" anchor="ctr"/>
+          <a:lstStyle/>
+          <a:p>
+            <a:pPr algn="ctr" indent="0" marL="0">
+              <a:buNone/>
+            </a:pPr>
+            <a:r>
+              <a:rPr lang="en-US" sz="1100" dirty="0">
+                <a:solidFill>
+                  <a:srgbClr val="8A93A6"/>
+                </a:solidFill>
+                <a:latin typeface="Calibri" pitchFamily="34" charset="0"/>
+                <a:ea typeface="Calibri" pitchFamily="34" charset="-122"/>
+                <a:cs typeface="Calibri" pitchFamily="34" charset="-120"/>
+              </a:rPr>
+              <a:t>Samuel Ferreira de Melo   ·   </a:t>
+            </a:r>
+            <a:pPr algn="ctr" indent="0" marL="0">
+              <a:buNone/>
+            </a:pPr>
+            <a:r>
+              <a:rPr lang="en-US" sz="1100" dirty="0">
+                <a:solidFill>
+                  <a:srgbClr val="FFFFFF"/>
+                </a:solidFill>
+                <a:latin typeface="Calibri" pitchFamily="34" charset="0"/>
+                <a:ea typeface="Calibri" pitchFamily="34" charset="-122"/>
+                <a:cs typeface="Calibri" pitchFamily="34" charset="-120"/>
+              </a:rPr>
+              <a:t>samuel.melo@engetecnica.com.br</a:t>
             </a:r>
             <a:endParaRPr lang="en-US" sz="1100" dirty="0"/>
           </a:p>
@@ -6615,14 +7761,75 @@
       </p:grpSpPr>
       <p:sp>
         <p:nvSpPr>
-          <p:cNvPr id="2" name="Text 0"/>
+          <p:cNvPr id="2" name="Shape 0"/>
           <p:cNvSpPr/>
           <p:nvPr/>
         </p:nvSpPr>
         <p:spPr>
           <a:xfrm>
             <a:off x="548640" y="457200"/>
-            <a:ext cx="10972800" cy="548640"/>
+            <a:ext cx="1691640" cy="365760"/>
+          </a:xfrm>
+          <a:prstGeom prst="roundRect">
+            <a:avLst>
+              <a:gd name="adj" fmla="val 12500"/>
+            </a:avLst>
+          </a:prstGeom>
+          <a:solidFill>
+            <a:srgbClr val="FF7639"/>
+          </a:solidFill>
+          <a:ln/>
+        </p:spPr>
+      </p:sp>
+      <p:sp>
+        <p:nvSpPr>
+          <p:cNvPr id="3" name="Text 1"/>
+          <p:cNvSpPr/>
+          <p:nvPr/>
+        </p:nvSpPr>
+        <p:spPr>
+          <a:xfrm>
+            <a:off x="548640" y="457200"/>
+            <a:ext cx="1691640" cy="365760"/>
+          </a:xfrm>
+          <a:prstGeom prst="rect">
+            <a:avLst/>
+          </a:prstGeom>
+          <a:noFill/>
+          <a:ln/>
+        </p:spPr>
+        <p:txBody>
+          <a:bodyPr wrap="square" lIns="0" tIns="0" rIns="0" bIns="0" rtlCol="0" anchor="ctr"/>
+          <a:lstStyle/>
+          <a:p>
+            <a:pPr algn="ctr" indent="0" marL="0">
+              <a:buNone/>
+            </a:pPr>
+            <a:r>
+              <a:rPr lang="en-US" sz="1200" b="1" spc="500" kern="0" dirty="0">
+                <a:solidFill>
+                  <a:srgbClr val="FFFFFF"/>
+                </a:solidFill>
+                <a:latin typeface="Calibri" pitchFamily="34" charset="0"/>
+                <a:ea typeface="Calibri" pitchFamily="34" charset="-122"/>
+                <a:cs typeface="Calibri" pitchFamily="34" charset="-120"/>
+              </a:rPr>
+              <a:t>CAMADA 4</a:t>
+            </a:r>
+            <a:endParaRPr lang="en-US" sz="1200" dirty="0"/>
+          </a:p>
+        </p:txBody>
+      </p:sp>
+      <p:sp>
+        <p:nvSpPr>
+          <p:cNvPr id="4" name="Text 2"/>
+          <p:cNvSpPr/>
+          <p:nvPr/>
+        </p:nvSpPr>
+        <p:spPr>
+          <a:xfrm>
+            <a:off x="548640" y="914400"/>
+            <a:ext cx="10972800" cy="594360"/>
           </a:xfrm>
           <a:prstGeom prst="rect">
             <a:avLst/>
@@ -6646,7 +7853,7 @@
                 <a:ea typeface="Cambria" pitchFamily="34" charset="-122"/>
                 <a:cs typeface="Cambria" pitchFamily="34" charset="-120"/>
               </a:rPr>
-              <a:t>Cronograma sugerido</a:t>
+              <a:t>Vídeo de treinamento (WhatsApp)</a:t>
             </a:r>
             <a:endParaRPr lang="en-US" sz="3200" dirty="0"/>
           </a:p>
@@ -6654,13 +7861,13 @@
       </p:sp>
       <p:sp>
         <p:nvSpPr>
-          <p:cNvPr id="3" name="Text 1"/>
-          <p:cNvSpPr/>
-          <p:nvPr/>
-        </p:nvSpPr>
-        <p:spPr>
-          <a:xfrm>
-            <a:off x="548640" y="960120"/>
+          <p:cNvPr id="5" name="Text 3"/>
+          <p:cNvSpPr/>
+          <p:nvPr/>
+        </p:nvSpPr>
+        <p:spPr>
+          <a:xfrm>
+            <a:off x="548640" y="1508760"/>
             <a:ext cx="10972800" cy="365760"/>
           </a:xfrm>
           <a:prstGeom prst="rect">
@@ -6677,7 +7884,7 @@
               <a:buNone/>
             </a:pPr>
             <a:r>
-              <a:rPr lang="en-US" sz="1500" dirty="0">
+              <a:rPr lang="en-US" sz="1400" dirty="0">
                 <a:solidFill>
                   <a:srgbClr val="5C6379"/>
                 </a:solidFill>
@@ -6685,6 +7892,826 @@
                 <a:ea typeface="Calibri" pitchFamily="34" charset="-122"/>
                 <a:cs typeface="Calibri" pitchFamily="34" charset="-120"/>
               </a:rPr>
+              <a:t>75 segundos · gravado pelo encarregado · no canal que a equipe já usa.</a:t>
+            </a:r>
+            <a:endParaRPr lang="en-US" sz="1400" dirty="0"/>
+          </a:p>
+        </p:txBody>
+      </p:sp>
+      <p:pic>
+        <p:nvPicPr>
+          <p:cNvPr id="6" name="Image 0" descr="C:\wamp64\www\app_engeativos_v002\proposta-checklist\04-storyboard-video.png">    </p:cNvPr>
+          <p:cNvPicPr>
+            <a:picLocks noChangeAspect="1"/>
+          </p:cNvPicPr>
+          <p:nvPr/>
+        </p:nvPicPr>
+        <p:blipFill>
+          <a:blip r:embed="rId1"/>
+          <a:srcRect l="0" r="0" t="0" b="0"/>
+          <a:stretch/>
+        </p:blipFill>
+        <p:spPr>
+          <a:xfrm>
+            <a:off x="548640" y="2011680"/>
+            <a:ext cx="7315200" cy="4434840"/>
+          </a:xfrm>
+          <a:prstGeom prst="rect">
+            <a:avLst/>
+          </a:prstGeom>
+        </p:spPr>
+      </p:pic>
+      <p:sp>
+        <p:nvSpPr>
+          <p:cNvPr id="7" name="Text 4"/>
+          <p:cNvSpPr/>
+          <p:nvPr/>
+        </p:nvSpPr>
+        <p:spPr>
+          <a:xfrm>
+            <a:off x="8138160" y="2057400"/>
+            <a:ext cx="3474720" cy="411480"/>
+          </a:xfrm>
+          <a:prstGeom prst="rect">
+            <a:avLst/>
+          </a:prstGeom>
+          <a:noFill/>
+          <a:ln/>
+        </p:spPr>
+        <p:txBody>
+          <a:bodyPr wrap="square" lIns="0" tIns="0" rIns="0" bIns="0" rtlCol="0" anchor="ctr"/>
+          <a:lstStyle/>
+          <a:p>
+            <a:pPr indent="0" marL="0">
+              <a:buNone/>
+            </a:pPr>
+            <a:r>
+              <a:rPr lang="en-US" sz="1500" b="1" dirty="0">
+                <a:solidFill>
+                  <a:srgbClr val="1E1E2E"/>
+                </a:solidFill>
+                <a:latin typeface="Calibri" pitchFamily="34" charset="0"/>
+                <a:ea typeface="Calibri" pitchFamily="34" charset="-122"/>
+                <a:cs typeface="Calibri" pitchFamily="34" charset="-120"/>
+              </a:rPr>
+              <a:t>Por que funciona pra esse público:</a:t>
+            </a:r>
+            <a:endParaRPr lang="en-US" sz="1500" dirty="0"/>
+          </a:p>
+        </p:txBody>
+      </p:sp>
+      <p:sp>
+        <p:nvSpPr>
+          <p:cNvPr id="8" name="Shape 5"/>
+          <p:cNvSpPr/>
+          <p:nvPr/>
+        </p:nvSpPr>
+        <p:spPr>
+          <a:xfrm>
+            <a:off x="8138160" y="2560320"/>
+            <a:ext cx="3474720" cy="438912"/>
+          </a:xfrm>
+          <a:prstGeom prst="roundRect">
+            <a:avLst>
+              <a:gd name="adj" fmla="val 12500"/>
+            </a:avLst>
+          </a:prstGeom>
+          <a:solidFill>
+            <a:srgbClr val="FFFFFF"/>
+          </a:solidFill>
+          <a:ln w="12700">
+            <a:solidFill>
+              <a:srgbClr val="E2E5EE"/>
+            </a:solidFill>
+            <a:prstDash val="solid"/>
+          </a:ln>
+        </p:spPr>
+      </p:sp>
+      <p:sp>
+        <p:nvSpPr>
+          <p:cNvPr id="9" name="Text 6"/>
+          <p:cNvSpPr/>
+          <p:nvPr/>
+        </p:nvSpPr>
+        <p:spPr>
+          <a:xfrm>
+            <a:off x="8229600" y="2560320"/>
+            <a:ext cx="457200" cy="438912"/>
+          </a:xfrm>
+          <a:prstGeom prst="rect">
+            <a:avLst/>
+          </a:prstGeom>
+          <a:noFill/>
+          <a:ln/>
+        </p:spPr>
+        <p:txBody>
+          <a:bodyPr wrap="square" lIns="0" tIns="0" rIns="0" bIns="0" rtlCol="0" anchor="ctr"/>
+          <a:lstStyle/>
+          <a:p>
+            <a:pPr algn="ctr" indent="0" marL="0">
+              <a:buNone/>
+            </a:pPr>
+            <a:r>
+              <a:rPr lang="en-US" sz="1800" dirty="0">
+                <a:solidFill>
+                  <a:srgbClr val="000000"/>
+                </a:solidFill>
+              </a:rPr>
+              <a:t>🗣</a:t>
+            </a:r>
+            <a:endParaRPr lang="en-US" sz="1800" dirty="0"/>
+          </a:p>
+        </p:txBody>
+      </p:sp>
+      <p:sp>
+        <p:nvSpPr>
+          <p:cNvPr id="10" name="Text 7"/>
+          <p:cNvSpPr/>
+          <p:nvPr/>
+        </p:nvSpPr>
+        <p:spPr>
+          <a:xfrm>
+            <a:off x="8732520" y="2560320"/>
+            <a:ext cx="2834640" cy="438912"/>
+          </a:xfrm>
+          <a:prstGeom prst="rect">
+            <a:avLst/>
+          </a:prstGeom>
+          <a:noFill/>
+          <a:ln/>
+        </p:spPr>
+        <p:txBody>
+          <a:bodyPr wrap="square" lIns="0" tIns="0" rIns="0" bIns="0" rtlCol="0" anchor="ctr"/>
+          <a:lstStyle/>
+          <a:p>
+            <a:pPr indent="0" marL="0">
+              <a:buNone/>
+            </a:pPr>
+            <a:r>
+              <a:rPr lang="en-US" sz="1200" dirty="0">
+                <a:solidFill>
+                  <a:srgbClr val="1E1E2E"/>
+                </a:solidFill>
+                <a:latin typeface="Calibri" pitchFamily="34" charset="0"/>
+                <a:ea typeface="Calibri" pitchFamily="34" charset="-122"/>
+                <a:cs typeface="Calibri" pitchFamily="34" charset="-120"/>
+              </a:rPr>
+              <a:t>Não exige leitura (voz + imagem)</a:t>
+            </a:r>
+            <a:endParaRPr lang="en-US" sz="1200" dirty="0"/>
+          </a:p>
+        </p:txBody>
+      </p:sp>
+      <p:sp>
+        <p:nvSpPr>
+          <p:cNvPr id="11" name="Shape 8"/>
+          <p:cNvSpPr/>
+          <p:nvPr/>
+        </p:nvSpPr>
+        <p:spPr>
+          <a:xfrm>
+            <a:off x="8138160" y="3063240"/>
+            <a:ext cx="3474720" cy="438912"/>
+          </a:xfrm>
+          <a:prstGeom prst="roundRect">
+            <a:avLst>
+              <a:gd name="adj" fmla="val 12500"/>
+            </a:avLst>
+          </a:prstGeom>
+          <a:solidFill>
+            <a:srgbClr val="FFFFFF"/>
+          </a:solidFill>
+          <a:ln w="12700">
+            <a:solidFill>
+              <a:srgbClr val="E2E5EE"/>
+            </a:solidFill>
+            <a:prstDash val="solid"/>
+          </a:ln>
+        </p:spPr>
+      </p:sp>
+      <p:sp>
+        <p:nvSpPr>
+          <p:cNvPr id="12" name="Text 9"/>
+          <p:cNvSpPr/>
+          <p:nvPr/>
+        </p:nvSpPr>
+        <p:spPr>
+          <a:xfrm>
+            <a:off x="8229600" y="3063240"/>
+            <a:ext cx="457200" cy="438912"/>
+          </a:xfrm>
+          <a:prstGeom prst="rect">
+            <a:avLst/>
+          </a:prstGeom>
+          <a:noFill/>
+          <a:ln/>
+        </p:spPr>
+        <p:txBody>
+          <a:bodyPr wrap="square" lIns="0" tIns="0" rIns="0" bIns="0" rtlCol="0" anchor="ctr"/>
+          <a:lstStyle/>
+          <a:p>
+            <a:pPr algn="ctr" indent="0" marL="0">
+              <a:buNone/>
+            </a:pPr>
+            <a:r>
+              <a:rPr lang="en-US" sz="1800" dirty="0">
+                <a:solidFill>
+                  <a:srgbClr val="000000"/>
+                </a:solidFill>
+              </a:rPr>
+              <a:t>👥</a:t>
+            </a:r>
+            <a:endParaRPr lang="en-US" sz="1800" dirty="0"/>
+          </a:p>
+        </p:txBody>
+      </p:sp>
+      <p:sp>
+        <p:nvSpPr>
+          <p:cNvPr id="13" name="Text 10"/>
+          <p:cNvSpPr/>
+          <p:nvPr/>
+        </p:nvSpPr>
+        <p:spPr>
+          <a:xfrm>
+            <a:off x="8732520" y="3063240"/>
+            <a:ext cx="2834640" cy="438912"/>
+          </a:xfrm>
+          <a:prstGeom prst="rect">
+            <a:avLst/>
+          </a:prstGeom>
+          <a:noFill/>
+          <a:ln/>
+        </p:spPr>
+        <p:txBody>
+          <a:bodyPr wrap="square" lIns="0" tIns="0" rIns="0" bIns="0" rtlCol="0" anchor="ctr"/>
+          <a:lstStyle/>
+          <a:p>
+            <a:pPr indent="0" marL="0">
+              <a:buNone/>
+            </a:pPr>
+            <a:r>
+              <a:rPr lang="en-US" sz="1200" dirty="0">
+                <a:solidFill>
+                  <a:srgbClr val="1E1E2E"/>
+                </a:solidFill>
+                <a:latin typeface="Calibri" pitchFamily="34" charset="0"/>
+                <a:ea typeface="Calibri" pitchFamily="34" charset="-122"/>
+                <a:cs typeface="Calibri" pitchFamily="34" charset="-120"/>
+              </a:rPr>
+              <a:t>Cara humana = confiança</a:t>
+            </a:r>
+            <a:endParaRPr lang="en-US" sz="1200" dirty="0"/>
+          </a:p>
+        </p:txBody>
+      </p:sp>
+      <p:sp>
+        <p:nvSpPr>
+          <p:cNvPr id="14" name="Shape 11"/>
+          <p:cNvSpPr/>
+          <p:nvPr/>
+        </p:nvSpPr>
+        <p:spPr>
+          <a:xfrm>
+            <a:off x="8138160" y="3566160"/>
+            <a:ext cx="3474720" cy="438912"/>
+          </a:xfrm>
+          <a:prstGeom prst="roundRect">
+            <a:avLst>
+              <a:gd name="adj" fmla="val 12500"/>
+            </a:avLst>
+          </a:prstGeom>
+          <a:solidFill>
+            <a:srgbClr val="FFFFFF"/>
+          </a:solidFill>
+          <a:ln w="12700">
+            <a:solidFill>
+              <a:srgbClr val="E2E5EE"/>
+            </a:solidFill>
+            <a:prstDash val="solid"/>
+          </a:ln>
+        </p:spPr>
+      </p:sp>
+      <p:sp>
+        <p:nvSpPr>
+          <p:cNvPr id="15" name="Text 12"/>
+          <p:cNvSpPr/>
+          <p:nvPr/>
+        </p:nvSpPr>
+        <p:spPr>
+          <a:xfrm>
+            <a:off x="8229600" y="3566160"/>
+            <a:ext cx="457200" cy="438912"/>
+          </a:xfrm>
+          <a:prstGeom prst="rect">
+            <a:avLst/>
+          </a:prstGeom>
+          <a:noFill/>
+          <a:ln/>
+        </p:spPr>
+        <p:txBody>
+          <a:bodyPr wrap="square" lIns="0" tIns="0" rIns="0" bIns="0" rtlCol="0" anchor="ctr"/>
+          <a:lstStyle/>
+          <a:p>
+            <a:pPr algn="ctr" indent="0" marL="0">
+              <a:buNone/>
+            </a:pPr>
+            <a:r>
+              <a:rPr lang="en-US" sz="1800" dirty="0">
+                <a:solidFill>
+                  <a:srgbClr val="000000"/>
+                </a:solidFill>
+              </a:rPr>
+              <a:t>💬</a:t>
+            </a:r>
+            <a:endParaRPr lang="en-US" sz="1800" dirty="0"/>
+          </a:p>
+        </p:txBody>
+      </p:sp>
+      <p:sp>
+        <p:nvSpPr>
+          <p:cNvPr id="16" name="Text 13"/>
+          <p:cNvSpPr/>
+          <p:nvPr/>
+        </p:nvSpPr>
+        <p:spPr>
+          <a:xfrm>
+            <a:off x="8732520" y="3566160"/>
+            <a:ext cx="2834640" cy="438912"/>
+          </a:xfrm>
+          <a:prstGeom prst="rect">
+            <a:avLst/>
+          </a:prstGeom>
+          <a:noFill/>
+          <a:ln/>
+        </p:spPr>
+        <p:txBody>
+          <a:bodyPr wrap="square" lIns="0" tIns="0" rIns="0" bIns="0" rtlCol="0" anchor="ctr"/>
+          <a:lstStyle/>
+          <a:p>
+            <a:pPr indent="0" marL="0">
+              <a:buNone/>
+            </a:pPr>
+            <a:r>
+              <a:rPr lang="en-US" sz="1200" dirty="0">
+                <a:solidFill>
+                  <a:srgbClr val="1E1E2E"/>
+                </a:solidFill>
+                <a:latin typeface="Calibri" pitchFamily="34" charset="0"/>
+                <a:ea typeface="Calibri" pitchFamily="34" charset="-122"/>
+                <a:cs typeface="Calibri" pitchFamily="34" charset="-120"/>
+              </a:rPr>
+              <a:t>WhatsApp é canal natural</a:t>
+            </a:r>
+            <a:endParaRPr lang="en-US" sz="1200" dirty="0"/>
+          </a:p>
+        </p:txBody>
+      </p:sp>
+      <p:sp>
+        <p:nvSpPr>
+          <p:cNvPr id="17" name="Shape 14"/>
+          <p:cNvSpPr/>
+          <p:nvPr/>
+        </p:nvSpPr>
+        <p:spPr>
+          <a:xfrm>
+            <a:off x="8138160" y="4069080"/>
+            <a:ext cx="3474720" cy="438912"/>
+          </a:xfrm>
+          <a:prstGeom prst="roundRect">
+            <a:avLst>
+              <a:gd name="adj" fmla="val 12500"/>
+            </a:avLst>
+          </a:prstGeom>
+          <a:solidFill>
+            <a:srgbClr val="FFFFFF"/>
+          </a:solidFill>
+          <a:ln w="12700">
+            <a:solidFill>
+              <a:srgbClr val="E2E5EE"/>
+            </a:solidFill>
+            <a:prstDash val="solid"/>
+          </a:ln>
+        </p:spPr>
+      </p:sp>
+      <p:sp>
+        <p:nvSpPr>
+          <p:cNvPr id="18" name="Text 15"/>
+          <p:cNvSpPr/>
+          <p:nvPr/>
+        </p:nvSpPr>
+        <p:spPr>
+          <a:xfrm>
+            <a:off x="8229600" y="4069080"/>
+            <a:ext cx="457200" cy="438912"/>
+          </a:xfrm>
+          <a:prstGeom prst="rect">
+            <a:avLst/>
+          </a:prstGeom>
+          <a:noFill/>
+          <a:ln/>
+        </p:spPr>
+        <p:txBody>
+          <a:bodyPr wrap="square" lIns="0" tIns="0" rIns="0" bIns="0" rtlCol="0" anchor="ctr"/>
+          <a:lstStyle/>
+          <a:p>
+            <a:pPr algn="ctr" indent="0" marL="0">
+              <a:buNone/>
+            </a:pPr>
+            <a:r>
+              <a:rPr lang="en-US" sz="1800" dirty="0">
+                <a:solidFill>
+                  <a:srgbClr val="000000"/>
+                </a:solidFill>
+              </a:rPr>
+              <a:t>🔁</a:t>
+            </a:r>
+            <a:endParaRPr lang="en-US" sz="1800" dirty="0"/>
+          </a:p>
+        </p:txBody>
+      </p:sp>
+      <p:sp>
+        <p:nvSpPr>
+          <p:cNvPr id="19" name="Text 16"/>
+          <p:cNvSpPr/>
+          <p:nvPr/>
+        </p:nvSpPr>
+        <p:spPr>
+          <a:xfrm>
+            <a:off x="8732520" y="4069080"/>
+            <a:ext cx="2834640" cy="438912"/>
+          </a:xfrm>
+          <a:prstGeom prst="rect">
+            <a:avLst/>
+          </a:prstGeom>
+          <a:noFill/>
+          <a:ln/>
+        </p:spPr>
+        <p:txBody>
+          <a:bodyPr wrap="square" lIns="0" tIns="0" rIns="0" bIns="0" rtlCol="0" anchor="ctr"/>
+          <a:lstStyle/>
+          <a:p>
+            <a:pPr indent="0" marL="0">
+              <a:buNone/>
+            </a:pPr>
+            <a:r>
+              <a:rPr lang="en-US" sz="1200" dirty="0">
+                <a:solidFill>
+                  <a:srgbClr val="1E1E2E"/>
+                </a:solidFill>
+                <a:latin typeface="Calibri" pitchFamily="34" charset="0"/>
+                <a:ea typeface="Calibri" pitchFamily="34" charset="-122"/>
+                <a:cs typeface="Calibri" pitchFamily="34" charset="-120"/>
+              </a:rPr>
+              <a:t>Repetível sob demanda</a:t>
+            </a:r>
+            <a:endParaRPr lang="en-US" sz="1200" dirty="0"/>
+          </a:p>
+        </p:txBody>
+      </p:sp>
+      <p:sp>
+        <p:nvSpPr>
+          <p:cNvPr id="20" name="Text 17"/>
+          <p:cNvSpPr/>
+          <p:nvPr/>
+        </p:nvSpPr>
+        <p:spPr>
+          <a:xfrm>
+            <a:off x="8138160" y="4663440"/>
+            <a:ext cx="3474720" cy="320040"/>
+          </a:xfrm>
+          <a:prstGeom prst="rect">
+            <a:avLst/>
+          </a:prstGeom>
+          <a:noFill/>
+          <a:ln/>
+        </p:spPr>
+        <p:txBody>
+          <a:bodyPr wrap="square" lIns="0" tIns="0" rIns="0" bIns="0" rtlCol="0" anchor="ctr"/>
+          <a:lstStyle/>
+          <a:p>
+            <a:pPr indent="0" marL="0">
+              <a:buNone/>
+            </a:pPr>
+            <a:r>
+              <a:rPr lang="en-US" sz="1300" b="1" dirty="0">
+                <a:solidFill>
+                  <a:srgbClr val="E54F0C"/>
+                </a:solidFill>
+                <a:latin typeface="Calibri" pitchFamily="34" charset="0"/>
+                <a:ea typeface="Calibri" pitchFamily="34" charset="-122"/>
+                <a:cs typeface="Calibri" pitchFamily="34" charset="-120"/>
+              </a:rPr>
+              <a:t>⚠️ Cuidados:</a:t>
+            </a:r>
+            <a:endParaRPr lang="en-US" sz="1300" dirty="0"/>
+          </a:p>
+        </p:txBody>
+      </p:sp>
+      <p:sp>
+        <p:nvSpPr>
+          <p:cNvPr id="21" name="Text 18"/>
+          <p:cNvSpPr/>
+          <p:nvPr/>
+        </p:nvSpPr>
+        <p:spPr>
+          <a:xfrm>
+            <a:off x="8138160" y="4983480"/>
+            <a:ext cx="3474720" cy="1051560"/>
+          </a:xfrm>
+          <a:prstGeom prst="rect">
+            <a:avLst/>
+          </a:prstGeom>
+          <a:noFill/>
+          <a:ln/>
+        </p:spPr>
+        <p:txBody>
+          <a:bodyPr wrap="square" lIns="0" tIns="0" rIns="0" bIns="0" rtlCol="0" anchor="ctr"/>
+          <a:lstStyle/>
+          <a:p>
+            <a:pPr indent="0" marL="0">
+              <a:buNone/>
+            </a:pPr>
+            <a:r>
+              <a:rPr lang="en-US" sz="1100" dirty="0">
+                <a:solidFill>
+                  <a:srgbClr val="1E1E2E"/>
+                </a:solidFill>
+                <a:latin typeface="Calibri" pitchFamily="34" charset="0"/>
+                <a:ea typeface="Calibri" pitchFamily="34" charset="-122"/>
+                <a:cs typeface="Calibri" pitchFamily="34" charset="-120"/>
+              </a:rPr>
+              <a:t>Máximo 75-90 s · </a:t>
+            </a:r>
+            <a:endParaRPr lang="en-US" sz="1100" dirty="0"/>
+          </a:p>
+          <a:p>
+            <a:pPr indent="0" marL="0">
+              <a:buNone/>
+            </a:pPr>
+            <a:r>
+              <a:rPr lang="en-US" sz="1100" dirty="0">
+                <a:solidFill>
+                  <a:srgbClr val="1E1E2E"/>
+                </a:solidFill>
+                <a:latin typeface="Calibri" pitchFamily="34" charset="0"/>
+                <a:ea typeface="Calibri" pitchFamily="34" charset="-122"/>
+                <a:cs typeface="Calibri" pitchFamily="34" charset="-120"/>
+              </a:rPr>
+              <a:t>Sem locutor profissional · </a:t>
+            </a:r>
+            <a:endParaRPr lang="en-US" sz="1100" dirty="0"/>
+          </a:p>
+          <a:p>
+            <a:pPr indent="0" marL="0">
+              <a:buNone/>
+            </a:pPr>
+            <a:r>
+              <a:rPr lang="en-US" sz="1100" dirty="0">
+                <a:solidFill>
+                  <a:srgbClr val="1E1E2E"/>
+                </a:solidFill>
+                <a:latin typeface="Calibri" pitchFamily="34" charset="0"/>
+                <a:ea typeface="Calibri" pitchFamily="34" charset="-122"/>
+                <a:cs typeface="Calibri" pitchFamily="34" charset="-120"/>
+              </a:rPr>
+              <a:t>Tela real do app, não mockup · </a:t>
+            </a:r>
+            <a:endParaRPr lang="en-US" sz="1100" dirty="0"/>
+          </a:p>
+          <a:p>
+            <a:pPr indent="0" marL="0">
+              <a:buNone/>
+            </a:pPr>
+            <a:r>
+              <a:rPr lang="en-US" sz="1100" dirty="0">
+                <a:solidFill>
+                  <a:srgbClr val="1E1E2E"/>
+                </a:solidFill>
+                <a:latin typeface="Calibri" pitchFamily="34" charset="0"/>
+                <a:ea typeface="Calibri" pitchFamily="34" charset="-122"/>
+                <a:cs typeface="Calibri" pitchFamily="34" charset="-120"/>
+              </a:rPr>
+              <a:t>Legendas obrigatórias</a:t>
+            </a:r>
+            <a:endParaRPr lang="en-US" sz="1100" dirty="0"/>
+          </a:p>
+        </p:txBody>
+      </p:sp>
+      <p:sp>
+        <p:nvSpPr>
+          <p:cNvPr id="22" name="Shape 19"/>
+          <p:cNvSpPr/>
+          <p:nvPr/>
+        </p:nvSpPr>
+        <p:spPr>
+          <a:xfrm>
+            <a:off x="8138160" y="6035040"/>
+            <a:ext cx="3474720" cy="594360"/>
+          </a:xfrm>
+          <a:prstGeom prst="roundRect">
+            <a:avLst>
+              <a:gd name="adj" fmla="val 12308"/>
+            </a:avLst>
+          </a:prstGeom>
+          <a:solidFill>
+            <a:srgbClr val="FFF5E6"/>
+          </a:solidFill>
+          <a:ln w="19050">
+            <a:solidFill>
+              <a:srgbClr val="FF7639"/>
+            </a:solidFill>
+            <a:prstDash val="solid"/>
+          </a:ln>
+        </p:spPr>
+      </p:sp>
+      <p:sp>
+        <p:nvSpPr>
+          <p:cNvPr id="23" name="Text 20"/>
+          <p:cNvSpPr/>
+          <p:nvPr/>
+        </p:nvSpPr>
+        <p:spPr>
+          <a:xfrm>
+            <a:off x="8275320" y="6035040"/>
+            <a:ext cx="3291840" cy="594360"/>
+          </a:xfrm>
+          <a:prstGeom prst="rect">
+            <a:avLst/>
+          </a:prstGeom>
+          <a:noFill/>
+          <a:ln/>
+        </p:spPr>
+        <p:txBody>
+          <a:bodyPr wrap="square" lIns="0" tIns="0" rIns="0" bIns="0" rtlCol="0" anchor="ctr"/>
+          <a:lstStyle/>
+          <a:p>
+            <a:pPr indent="0" marL="0">
+              <a:buNone/>
+            </a:pPr>
+            <a:r>
+              <a:rPr lang="en-US" sz="1200" b="1" dirty="0">
+                <a:solidFill>
+                  <a:srgbClr val="E54F0C"/>
+                </a:solidFill>
+                <a:latin typeface="Calibri" pitchFamily="34" charset="0"/>
+                <a:ea typeface="Calibri" pitchFamily="34" charset="-122"/>
+                <a:cs typeface="Calibri" pitchFamily="34" charset="-120"/>
+              </a:rPr>
+              <a:t>Custo: </a:t>
+            </a:r>
+            <a:pPr indent="0" marL="0">
+              <a:buNone/>
+            </a:pPr>
+            <a:r>
+              <a:rPr lang="en-US" sz="1200" dirty="0">
+                <a:solidFill>
+                  <a:srgbClr val="E54F0C"/>
+                </a:solidFill>
+                <a:latin typeface="Calibri" pitchFamily="34" charset="0"/>
+                <a:ea typeface="Calibri" pitchFamily="34" charset="-122"/>
+                <a:cs typeface="Calibri" pitchFamily="34" charset="-120"/>
+              </a:rPr>
+              <a:t>R$ 0 · ~3 h encarregado</a:t>
+            </a:r>
+            <a:endParaRPr lang="en-US" sz="1200" dirty="0"/>
+          </a:p>
+          <a:p>
+            <a:pPr indent="0" marL="0">
+              <a:buNone/>
+            </a:pPr>
+            <a:r>
+              <a:rPr lang="en-US" sz="1200" b="1" dirty="0">
+                <a:solidFill>
+                  <a:srgbClr val="E54F0C"/>
+                </a:solidFill>
+                <a:latin typeface="Calibri" pitchFamily="34" charset="0"/>
+                <a:ea typeface="Calibri" pitchFamily="34" charset="-122"/>
+                <a:cs typeface="Calibri" pitchFamily="34" charset="-120"/>
+              </a:rPr>
+              <a:t>Risco: </a:t>
+            </a:r>
+            <a:pPr indent="0" marL="0">
+              <a:buNone/>
+            </a:pPr>
+            <a:r>
+              <a:rPr lang="en-US" sz="1200" dirty="0">
+                <a:solidFill>
+                  <a:srgbClr val="E54F0C"/>
+                </a:solidFill>
+                <a:latin typeface="Calibri" pitchFamily="34" charset="0"/>
+                <a:ea typeface="Calibri" pitchFamily="34" charset="-122"/>
+                <a:cs typeface="Calibri" pitchFamily="34" charset="-120"/>
+              </a:rPr>
+              <a:t>zero</a:t>
+            </a:r>
+            <a:endParaRPr lang="en-US" sz="1200" dirty="0"/>
+          </a:p>
+        </p:txBody>
+      </p:sp>
+    </p:spTree>
+  </p:cSld>
+  <p:clrMapOvr>
+    <a:masterClrMapping/>
+  </p:clrMapOvr>
+</p:sld>
+</file>
+
+<file path=ppt/slides/slide9.xml><?xml version="1.0" encoding="utf-8"?>
+<p:sld xmlns:a="http://schemas.openxmlformats.org/drawingml/2006/main" xmlns:r="http://schemas.openxmlformats.org/officeDocument/2006/relationships" xmlns:p="http://schemas.openxmlformats.org/presentationml/2006/main">
+  <p:cSld name="Slide 9">
+    <p:bg>
+      <p:bgPr>
+        <a:solidFill>
+          <a:srgbClr val="F7F8FC"/>
+        </a:solidFill>
+      </p:bgPr>
+    </p:bg>
+    <p:spTree>
+      <p:nvGrpSpPr>
+        <p:cNvPr id="1" name=""/>
+        <p:cNvGrpSpPr/>
+        <p:nvPr/>
+      </p:nvGrpSpPr>
+      <p:grpSpPr>
+        <a:xfrm>
+          <a:off x="0" y="0"/>
+          <a:ext cx="0" cy="0"/>
+          <a:chOff x="0" y="0"/>
+          <a:chExt cx="0" cy="0"/>
+        </a:xfrm>
+      </p:grpSpPr>
+      <p:sp>
+        <p:nvSpPr>
+          <p:cNvPr id="2" name="Text 0"/>
+          <p:cNvSpPr/>
+          <p:nvPr/>
+        </p:nvSpPr>
+        <p:spPr>
+          <a:xfrm>
+            <a:off x="548640" y="457200"/>
+            <a:ext cx="10972800" cy="548640"/>
+          </a:xfrm>
+          <a:prstGeom prst="rect">
+            <a:avLst/>
+          </a:prstGeom>
+          <a:noFill/>
+          <a:ln/>
+        </p:spPr>
+        <p:txBody>
+          <a:bodyPr wrap="square" lIns="0" tIns="0" rIns="0" bIns="0" rtlCol="0" anchor="ctr"/>
+          <a:lstStyle/>
+          <a:p>
+            <a:pPr indent="0" marL="0">
+              <a:buNone/>
+            </a:pPr>
+            <a:r>
+              <a:rPr lang="en-US" sz="3200" b="1" dirty="0">
+                <a:solidFill>
+                  <a:srgbClr val="1E1E2E"/>
+                </a:solidFill>
+                <a:latin typeface="Cambria" pitchFamily="34" charset="0"/>
+                <a:ea typeface="Cambria" pitchFamily="34" charset="-122"/>
+                <a:cs typeface="Cambria" pitchFamily="34" charset="-120"/>
+              </a:rPr>
+              <a:t>Cronograma sugerido</a:t>
+            </a:r>
+            <a:endParaRPr lang="en-US" sz="3200" dirty="0"/>
+          </a:p>
+        </p:txBody>
+      </p:sp>
+      <p:sp>
+        <p:nvSpPr>
+          <p:cNvPr id="3" name="Text 1"/>
+          <p:cNvSpPr/>
+          <p:nvPr/>
+        </p:nvSpPr>
+        <p:spPr>
+          <a:xfrm>
+            <a:off x="548640" y="960120"/>
+            <a:ext cx="10972800" cy="365760"/>
+          </a:xfrm>
+          <a:prstGeom prst="rect">
+            <a:avLst/>
+          </a:prstGeom>
+          <a:noFill/>
+          <a:ln/>
+        </p:spPr>
+        <p:txBody>
+          <a:bodyPr wrap="square" lIns="0" tIns="0" rIns="0" bIns="0" rtlCol="0" anchor="ctr"/>
+          <a:lstStyle/>
+          <a:p>
+            <a:pPr indent="0" marL="0">
+              <a:buNone/>
+            </a:pPr>
+            <a:r>
+              <a:rPr lang="en-US" sz="1500" dirty="0">
+                <a:solidFill>
+                  <a:srgbClr val="5C6379"/>
+                </a:solidFill>
+                <a:latin typeface="Calibri" pitchFamily="34" charset="0"/>
+                <a:ea typeface="Calibri" pitchFamily="34" charset="-122"/>
+                <a:cs typeface="Calibri" pitchFamily="34" charset="-120"/>
+              </a:rPr>
               <a:t>4 semanas do OK ao primeiro KPI medido.</a:t>
             </a:r>
             <a:endParaRPr lang="en-US" sz="1500" dirty="0"/>
@@ -6693,7 +8720,7 @@
       </p:sp>
       <p:graphicFrame>
         <p:nvGraphicFramePr>
-          <p:cNvPr id="9" name="Table 0"/>
+          <p:cNvPr id="10" name="Table 0"/>
           <p:cNvGraphicFramePr>
             <a:graphicFrameLocks noGrp="1"/>
           </p:cNvGraphicFramePr>
@@ -6715,8 +8742,8 @@
               <a:tblPr/>
               <a:tblGrid>
                 <a:gridCol w="1188720"/>
-                <a:gridCol w="5669280"/>
-                <a:gridCol w="2560320"/>
+                <a:gridCol w="5486400"/>
+                <a:gridCol w="2743200"/>
                 <a:gridCol w="1645920"/>
               </a:tblGrid>
               <a:tr h="502920">
@@ -6729,7 +8756,7 @@
                         <a:buNone/>
                       </a:pPr>
                       <a:r>
-                        <a:rPr lang="en-US" sz="1300" b="1" dirty="0">
+                        <a:rPr lang="en-US" sz="1250" b="1" dirty="0">
                           <a:solidFill>
                             <a:srgbClr val="FFFFFF"/>
                           </a:solidFill>
@@ -6739,7 +8766,7 @@
                         </a:rPr>
                         <a:t>Semana</a:t>
                       </a:r>
-                      <a:endParaRPr lang="en-US" sz="1300" dirty="0">
+                      <a:endParaRPr lang="en-US" sz="1250" dirty="0">
                         <a:latin typeface="Calibri" charset="0"/>
                         <a:ea typeface="Calibri" charset="0"/>
                         <a:cs typeface="Calibri" charset="0"/>
@@ -6797,7 +8824,7 @@
                         <a:buNone/>
                       </a:pPr>
                       <a:r>
-                        <a:rPr lang="en-US" sz="1300" b="1" dirty="0">
+                        <a:rPr lang="en-US" sz="1250" b="1" dirty="0">
                           <a:solidFill>
                             <a:srgbClr val="FFFFFF"/>
                           </a:solidFill>
@@ -6807,7 +8834,7 @@
                         </a:rPr>
                         <a:t>Ação</a:t>
                       </a:r>
-                      <a:endParaRPr lang="en-US" sz="1300" dirty="0">
+                      <a:endParaRPr lang="en-US" sz="1250" dirty="0">
                         <a:latin typeface="Calibri" charset="0"/>
                         <a:ea typeface="Calibri" charset="0"/>
                         <a:cs typeface="Calibri" charset="0"/>
@@ -6865,7 +8892,7 @@
                         <a:buNone/>
                       </a:pPr>
                       <a:r>
-                        <a:rPr lang="en-US" sz="1300" b="1" dirty="0">
+                        <a:rPr lang="en-US" sz="1250" b="1" dirty="0">
                           <a:solidFill>
                             <a:srgbClr val="FFFFFF"/>
                           </a:solidFill>
@@ -6875,7 +8902,7 @@
                         </a:rPr>
                         <a:t>Responsável</a:t>
                       </a:r>
-                      <a:endParaRPr lang="en-US" sz="1300" dirty="0">
+                      <a:endParaRPr lang="en-US" sz="1250" dirty="0">
                         <a:latin typeface="Calibri" charset="0"/>
                         <a:ea typeface="Calibri" charset="0"/>
                         <a:cs typeface="Calibri" charset="0"/>
@@ -6933,7 +8960,7 @@
                         <a:buNone/>
                       </a:pPr>
                       <a:r>
-                        <a:rPr lang="en-US" sz="1300" b="1" dirty="0">
+                        <a:rPr lang="en-US" sz="1250" b="1" dirty="0">
                           <a:solidFill>
                             <a:srgbClr val="FFFFFF"/>
                           </a:solidFill>
@@ -6943,7 +8970,7 @@
                         </a:rPr>
                         <a:t>Custo</a:t>
                       </a:r>
-                      <a:endParaRPr lang="en-US" sz="1300" dirty="0">
+                      <a:endParaRPr lang="en-US" sz="1250" dirty="0">
                         <a:latin typeface="Calibri" charset="0"/>
                         <a:ea typeface="Calibri" charset="0"/>
                         <a:cs typeface="Calibri" charset="0"/>
@@ -6993,7 +9020,7 @@
                   </a:tcPr>
                 </a:tc>
               </a:tr>
-              <a:tr h="868680">
+              <a:tr h="914400">
                 <a:tc>
                   <a:txBody>
                     <a:bodyPr/>
@@ -7071,7 +9098,7 @@
                         <a:buNone/>
                       </a:pPr>
                       <a:r>
-                        <a:rPr lang="en-US" sz="1300" dirty="0">
+                        <a:rPr lang="en-US" sz="1250" dirty="0">
                           <a:solidFill>
                             <a:srgbClr val="1E1E2E"/>
                           </a:solidFill>
@@ -7079,9 +9106,9 @@
                           <a:ea typeface="Calibri" pitchFamily="34" charset="-122"/>
                           <a:cs typeface="Calibri" pitchFamily="34" charset="-120"/>
                         </a:rPr>
-                        <a:t>Aprovação da proposta + refazer tutorial (Camada 1)</a:t>
+                        <a:t>Aprovação + refazer tutorial (C1) + gravar vídeo WhatsApp (C4)</a:t>
                       </a:r>
-                      <a:endParaRPr lang="en-US" sz="1300" dirty="0">
+                      <a:endParaRPr lang="en-US" sz="1250" dirty="0">
                         <a:latin typeface="Calibri" charset="0"/>
                         <a:ea typeface="Calibri" charset="0"/>
                         <a:cs typeface="Calibri" charset="0"/>
@@ -7139,7 +9166,7 @@
                         <a:buNone/>
                       </a:pPr>
                       <a:r>
-                        <a:rPr lang="en-US" sz="1300" dirty="0">
+                        <a:rPr lang="en-US" sz="1250" dirty="0">
                           <a:solidFill>
                             <a:srgbClr val="1E1E2E"/>
                           </a:solidFill>
@@ -7147,9 +9174,9 @@
                           <a:ea typeface="Calibri" pitchFamily="34" charset="-122"/>
                           <a:cs typeface="Calibri" pitchFamily="34" charset="-120"/>
                         </a:rPr>
-                        <a:t>Gerente · TI</a:t>
+                        <a:t>Gerente · TI · Encarregado</a:t>
                       </a:r>
-                      <a:endParaRPr lang="en-US" sz="1300" dirty="0">
+                      <a:endParaRPr lang="en-US" sz="1250" dirty="0">
                         <a:latin typeface="Calibri" charset="0"/>
                         <a:ea typeface="Calibri" charset="0"/>
                         <a:cs typeface="Calibri" charset="0"/>
@@ -7207,7 +9234,7 @@
                         <a:buNone/>
                       </a:pPr>
                       <a:r>
-                        <a:rPr lang="en-US" sz="1300" dirty="0">
+                        <a:rPr lang="en-US" sz="1250" dirty="0">
                           <a:solidFill>
                             <a:srgbClr val="1E1E2E"/>
                           </a:solidFill>
@@ -7215,9 +9242,9 @@
                           <a:ea typeface="Calibri" pitchFamily="34" charset="-122"/>
                           <a:cs typeface="Calibri" pitchFamily="34" charset="-120"/>
                         </a:rPr>
-                        <a:t>~4 h dev</a:t>
+                        <a:t>~4 h dev + ~3 h grav.</a:t>
                       </a:r>
-                      <a:endParaRPr lang="en-US" sz="1300" dirty="0">
+                      <a:endParaRPr lang="en-US" sz="1250" dirty="0">
                         <a:latin typeface="Calibri" charset="0"/>
                         <a:ea typeface="Calibri" charset="0"/>
                         <a:cs typeface="Calibri" charset="0"/>
@@ -7267,7 +9294,7 @@
                   </a:tcPr>
                 </a:tc>
               </a:tr>
-              <a:tr h="960120">
+              <a:tr h="914400">
                 <a:tc>
                   <a:txBody>
                     <a:bodyPr/>
@@ -7345,7 +9372,7 @@
                         <a:buNone/>
                       </a:pPr>
                       <a:r>
-                        <a:rPr lang="en-US" sz="1300" dirty="0">
+                        <a:rPr lang="en-US" sz="1250" dirty="0">
                           <a:solidFill>
                             <a:srgbClr val="1E1E2E"/>
                           </a:solidFill>
@@ -7353,9 +9380,9 @@
                           <a:ea typeface="Calibri" pitchFamily="34" charset="-122"/>
                           <a:cs typeface="Calibri" pitchFamily="34" charset="-120"/>
                         </a:rPr>
-                        <a:t>Implementar mudanças no app (Camada 2) + imprimir cartões A5 (Camada 3)</a:t>
+                        <a:t>Implementar mudanças no app (C2) + imprimir cartões A5 (C3)</a:t>
                       </a:r>
-                      <a:endParaRPr lang="en-US" sz="1300" dirty="0">
+                      <a:endParaRPr lang="en-US" sz="1250" dirty="0">
                         <a:latin typeface="Calibri" charset="0"/>
                         <a:ea typeface="Calibri" charset="0"/>
                         <a:cs typeface="Calibri" charset="0"/>
@@ -7413,7 +9440,7 @@
                         <a:buNone/>
                       </a:pPr>
                       <a:r>
-                        <a:rPr lang="en-US" sz="1300" dirty="0">
+                        <a:rPr lang="en-US" sz="1250" dirty="0">
                           <a:solidFill>
                             <a:srgbClr val="1E1E2E"/>
                           </a:solidFill>
@@ -7423,7 +9450,7 @@
                         </a:rPr>
                         <a:t>TI · Gráfica</a:t>
                       </a:r>
-                      <a:endParaRPr lang="en-US" sz="1300" dirty="0">
+                      <a:endParaRPr lang="en-US" sz="1250" dirty="0">
                         <a:latin typeface="Calibri" charset="0"/>
                         <a:ea typeface="Calibri" charset="0"/>
                         <a:cs typeface="Calibri" charset="0"/>
@@ -7481,7 +9508,7 @@
                         <a:buNone/>
                       </a:pPr>
                       <a:r>
-                        <a:rPr lang="en-US" sz="1300" dirty="0">
+                        <a:rPr lang="en-US" sz="1250" dirty="0">
                           <a:solidFill>
                             <a:srgbClr val="1E1E2E"/>
                           </a:solidFill>
@@ -7491,7 +9518,7 @@
                         </a:rPr>
                         <a:t>~3 dias dev + R$ 5/un</a:t>
                       </a:r>
-                      <a:endParaRPr lang="en-US" sz="1300" dirty="0">
+                      <a:endParaRPr lang="en-US" sz="1250" dirty="0">
                         <a:latin typeface="Calibri" charset="0"/>
                         <a:ea typeface="Calibri" charset="0"/>
                         <a:cs typeface="Calibri" charset="0"/>
@@ -7541,7 +9568,7 @@
                   </a:tcPr>
                 </a:tc>
               </a:tr>
-              <a:tr h="868680">
+              <a:tr h="914400">
                 <a:tc>
                   <a:txBody>
                     <a:bodyPr/>
@@ -7619,7 +9646,7 @@
                         <a:buNone/>
                       </a:pPr>
                       <a:r>
-                        <a:rPr lang="en-US" sz="1300" dirty="0">
+                        <a:rPr lang="en-US" sz="1250" dirty="0">
                           <a:solidFill>
                             <a:srgbClr val="1E1E2E"/>
                           </a:solidFill>
@@ -7627,9 +9654,9 @@
                           <a:ea typeface="Calibri" pitchFamily="34" charset="-122"/>
                           <a:cs typeface="Calibri" pitchFamily="34" charset="-120"/>
                         </a:rPr>
-                        <a:t>Lançar nova versão do app + distribuir cartões nos veículos</a:t>
+                        <a:t>Lançar nova versão do app + distribuir cartões + repostar vídeo no grupo</a:t>
                       </a:r>
-                      <a:endParaRPr lang="en-US" sz="1300" dirty="0">
+                      <a:endParaRPr lang="en-US" sz="1250" dirty="0">
                         <a:latin typeface="Calibri" charset="0"/>
                         <a:ea typeface="Calibri" charset="0"/>
                         <a:cs typeface="Calibri" charset="0"/>
@@ -7687,7 +9714,7 @@
                         <a:buNone/>
                       </a:pPr>
                       <a:r>
-                        <a:rPr lang="en-US" sz="1300" dirty="0">
+                        <a:rPr lang="en-US" sz="1250" dirty="0">
                           <a:solidFill>
                             <a:srgbClr val="1E1E2E"/>
                           </a:solidFill>
@@ -7697,7 +9724,7 @@
                         </a:rPr>
                         <a:t>TI · Encarregado</a:t>
                       </a:r>
-                      <a:endParaRPr lang="en-US" sz="1300" dirty="0">
+                      <a:endParaRPr lang="en-US" sz="1250" dirty="0">
                         <a:latin typeface="Calibri" charset="0"/>
                         <a:ea typeface="Calibri" charset="0"/>
                         <a:cs typeface="Calibri" charset="0"/>
@@ -7755,7 +9782,7 @@
                         <a:buNone/>
                       </a:pPr>
                       <a:r>
-                        <a:rPr lang="en-US" sz="1300" dirty="0">
+                        <a:rPr lang="en-US" sz="1250" dirty="0">
                           <a:solidFill>
                             <a:srgbClr val="1E1E2E"/>
                           </a:solidFill>
@@ -7765,7 +9792,7 @@
                         </a:rPr>
                         <a:t>—</a:t>
                       </a:r>
-                      <a:endParaRPr lang="en-US" sz="1300" dirty="0">
+                      <a:endParaRPr lang="en-US" sz="1250" dirty="0">
                         <a:latin typeface="Calibri" charset="0"/>
                         <a:ea typeface="Calibri" charset="0"/>
                         <a:cs typeface="Calibri" charset="0"/>
@@ -7815,7 +9842,7 @@
                   </a:tcPr>
                 </a:tc>
               </a:tr>
-              <a:tr h="868680">
+              <a:tr h="914400">
                 <a:tc>
                   <a:txBody>
                     <a:bodyPr/>
@@ -7893,7 +9920,7 @@
                         <a:buNone/>
                       </a:pPr>
                       <a:r>
-                        <a:rPr lang="en-US" sz="1300" dirty="0">
+                        <a:rPr lang="en-US" sz="1250" dirty="0">
                           <a:solidFill>
                             <a:srgbClr val="1E1E2E"/>
                           </a:solidFill>
@@ -7903,7 +9930,7 @@
                         </a:rPr>
                         <a:t>Medir queda em "turnos abertos sem encerrar" (1ª leitura do KPI)</a:t>
                       </a:r>
-                      <a:endParaRPr lang="en-US" sz="1300" dirty="0">
+                      <a:endParaRPr lang="en-US" sz="1250" dirty="0">
                         <a:latin typeface="Calibri" charset="0"/>
                         <a:ea typeface="Calibri" charset="0"/>
                         <a:cs typeface="Calibri" charset="0"/>
@@ -7961,7 +9988,7 @@
                         <a:buNone/>
                       </a:pPr>
                       <a:r>
-                        <a:rPr lang="en-US" sz="1300" dirty="0">
+                        <a:rPr lang="en-US" sz="1250" dirty="0">
                           <a:solidFill>
                             <a:srgbClr val="1E1E2E"/>
                           </a:solidFill>
@@ -7971,7 +9998,7 @@
                         </a:rPr>
                         <a:t>Gerente</a:t>
                       </a:r>
-                      <a:endParaRPr lang="en-US" sz="1300" dirty="0">
+                      <a:endParaRPr lang="en-US" sz="1250" dirty="0">
                         <a:latin typeface="Calibri" charset="0"/>
                         <a:ea typeface="Calibri" charset="0"/>
                         <a:cs typeface="Calibri" charset="0"/>
@@ -8029,7 +10056,7 @@
                         <a:buNone/>
                       </a:pPr>
                       <a:r>
-                        <a:rPr lang="en-US" sz="1300" dirty="0">
+                        <a:rPr lang="en-US" sz="1250" dirty="0">
                           <a:solidFill>
                             <a:srgbClr val="1E1E2E"/>
                           </a:solidFill>
@@ -8039,7 +10066,7 @@
                         </a:rPr>
                         <a:t>—</a:t>
                       </a:r>
-                      <a:endParaRPr lang="en-US" sz="1300" dirty="0">
+                      <a:endParaRPr lang="en-US" sz="1250" dirty="0">
                         <a:latin typeface="Calibri" charset="0"/>
                         <a:ea typeface="Calibri" charset="0"/>
                         <a:cs typeface="Calibri" charset="0"/>
@@ -8140,7 +10167,7 @@
               <a:buNone/>
             </a:pPr>
             <a:r>
-              <a:rPr lang="en-US" sz="1400" b="1" dirty="0">
+              <a:rPr lang="en-US" sz="1300" b="1" dirty="0">
                 <a:solidFill>
                   <a:srgbClr val="FF7639"/>
                 </a:solidFill>
@@ -8154,7 +10181,7 @@
               <a:buNone/>
             </a:pPr>
             <a:r>
-              <a:rPr lang="en-US" sz="1400" dirty="0">
+              <a:rPr lang="en-US" sz="1300" dirty="0">
                 <a:solidFill>
                   <a:srgbClr val="FFFFFF"/>
                 </a:solidFill>
@@ -8168,7 +10195,7 @@
               <a:buNone/>
             </a:pPr>
             <a:r>
-              <a:rPr lang="en-US" sz="1400" dirty="0">
+              <a:rPr lang="en-US" sz="1300" dirty="0">
                 <a:solidFill>
                   <a:srgbClr val="FFFFFF"/>
                 </a:solidFill>
@@ -8176,13 +10203,13 @@
                 <a:ea typeface="Calibri" pitchFamily="34" charset="-122"/>
                 <a:cs typeface="Calibri" pitchFamily="34" charset="-120"/>
               </a:rPr>
-              <a:t>&lt; 8 h de desenvolvimento  ·  </a:t>
+              <a:t>&lt; 8 h de dev  ·  </a:t>
             </a:r>
             <a:pPr algn="ctr" indent="0" marL="0">
               <a:buNone/>
             </a:pPr>
             <a:r>
-              <a:rPr lang="en-US" sz="1400" dirty="0">
+              <a:rPr lang="en-US" sz="1300" dirty="0">
                 <a:solidFill>
                   <a:srgbClr val="FFFFFF"/>
                 </a:solidFill>
@@ -8190,918 +10217,23 @@
                 <a:ea typeface="Calibri" pitchFamily="34" charset="-122"/>
                 <a:cs typeface="Calibri" pitchFamily="34" charset="-120"/>
               </a:rPr>
-              <a:t>R$ 5 × frota (uma vez)</a:t>
-            </a:r>
-            <a:endParaRPr lang="en-US" sz="1400" dirty="0"/>
-          </a:p>
-        </p:txBody>
-      </p:sp>
-    </p:spTree>
-  </p:cSld>
-  <p:clrMapOvr>
-    <a:masterClrMapping/>
-  </p:clrMapOvr>
-</p:sld>
-</file>
-
-<file path=ppt/slides/slide9.xml><?xml version="1.0" encoding="utf-8"?>
-<p:sld xmlns:a="http://schemas.openxmlformats.org/drawingml/2006/main" xmlns:r="http://schemas.openxmlformats.org/officeDocument/2006/relationships" xmlns:p="http://schemas.openxmlformats.org/presentationml/2006/main">
-  <p:cSld name="Slide 9">
-    <p:bg>
-      <p:bgPr>
-        <a:solidFill>
-          <a:srgbClr val="141A35"/>
-        </a:solidFill>
-      </p:bgPr>
-    </p:bg>
-    <p:spTree>
-      <p:nvGrpSpPr>
-        <p:cNvPr id="1" name=""/>
-        <p:cNvGrpSpPr/>
-        <p:nvPr/>
-      </p:nvGrpSpPr>
-      <p:grpSpPr>
-        <a:xfrm>
-          <a:off x="0" y="0"/>
-          <a:ext cx="0" cy="0"/>
-          <a:chOff x="0" y="0"/>
-          <a:chExt cx="0" cy="0"/>
-        </a:xfrm>
-      </p:grpSpPr>
-      <p:sp>
-        <p:nvSpPr>
-          <p:cNvPr id="2" name="Shape 0"/>
-          <p:cNvSpPr/>
-          <p:nvPr/>
-        </p:nvSpPr>
-        <p:spPr>
-          <a:xfrm>
-            <a:off x="-2286000" y="-2286000"/>
-            <a:ext cx="5486400" cy="5486400"/>
-          </a:xfrm>
-          <a:prstGeom prst="ellipse">
-            <a:avLst/>
-          </a:prstGeom>
-          <a:solidFill>
-            <a:srgbClr val="FF7639">
-              <a:alpha val="20000"/>
-            </a:srgbClr>
-          </a:solidFill>
-          <a:ln/>
-        </p:spPr>
-      </p:sp>
-      <p:sp>
-        <p:nvSpPr>
-          <p:cNvPr id="3" name="Shape 1"/>
-          <p:cNvSpPr/>
-          <p:nvPr/>
-        </p:nvSpPr>
-        <p:spPr>
-          <a:xfrm>
-            <a:off x="9144000" y="4114800"/>
-            <a:ext cx="5029200" cy="5029200"/>
-          </a:xfrm>
-          <a:prstGeom prst="ellipse">
-            <a:avLst/>
-          </a:prstGeom>
-          <a:solidFill>
-            <a:srgbClr val="22B07D">
-              <a:alpha val="20000"/>
-            </a:srgbClr>
-          </a:solidFill>
-          <a:ln/>
-        </p:spPr>
-      </p:sp>
-      <p:sp>
-        <p:nvSpPr>
-          <p:cNvPr id="4" name="Text 2"/>
-          <p:cNvSpPr/>
-          <p:nvPr/>
-        </p:nvSpPr>
-        <p:spPr>
-          <a:xfrm>
-            <a:off x="548640" y="457200"/>
-            <a:ext cx="10972800" cy="640080"/>
-          </a:xfrm>
-          <a:prstGeom prst="rect">
-            <a:avLst/>
-          </a:prstGeom>
-          <a:noFill/>
-          <a:ln/>
-        </p:spPr>
-        <p:txBody>
-          <a:bodyPr wrap="square" lIns="0" tIns="0" rIns="0" bIns="0" rtlCol="0" anchor="ctr"/>
-          <a:lstStyle/>
-          <a:p>
-            <a:pPr indent="0" marL="0">
-              <a:buNone/>
-            </a:pPr>
-            <a:r>
-              <a:rPr lang="en-US" sz="3800" b="1" dirty="0">
+              <a:t>~3 h do encarregado  ·  </a:t>
+            </a:r>
+            <a:pPr algn="ctr" indent="0" marL="0">
+              <a:buNone/>
+            </a:pPr>
+            <a:r>
+              <a:rPr lang="en-US" sz="1300" dirty="0">
                 <a:solidFill>
                   <a:srgbClr val="FFFFFF"/>
-                </a:solidFill>
-                <a:latin typeface="Cambria" pitchFamily="34" charset="0"/>
-                <a:ea typeface="Cambria" pitchFamily="34" charset="-122"/>
-                <a:cs typeface="Cambria" pitchFamily="34" charset="-120"/>
-              </a:rPr>
-              <a:t>Decisão</a:t>
-            </a:r>
-            <a:endParaRPr lang="en-US" sz="3800" dirty="0"/>
-          </a:p>
-        </p:txBody>
-      </p:sp>
-      <p:sp>
-        <p:nvSpPr>
-          <p:cNvPr id="5" name="Text 3"/>
-          <p:cNvSpPr/>
-          <p:nvPr/>
-        </p:nvSpPr>
-        <p:spPr>
-          <a:xfrm>
-            <a:off x="548640" y="1097280"/>
-            <a:ext cx="10972800" cy="365760"/>
-          </a:xfrm>
-          <a:prstGeom prst="rect">
-            <a:avLst/>
-          </a:prstGeom>
-          <a:noFill/>
-          <a:ln/>
-        </p:spPr>
-        <p:txBody>
-          <a:bodyPr wrap="square" lIns="0" tIns="0" rIns="0" bIns="0" rtlCol="0" anchor="ctr"/>
-          <a:lstStyle/>
-          <a:p>
-            <a:pPr indent="0" marL="0">
-              <a:buNone/>
-            </a:pPr>
-            <a:r>
-              <a:rPr lang="en-US" sz="1500" dirty="0">
-                <a:solidFill>
-                  <a:srgbClr val="B9C2D6"/>
                 </a:solidFill>
                 <a:latin typeface="Calibri" pitchFamily="34" charset="0"/>
                 <a:ea typeface="Calibri" pitchFamily="34" charset="-122"/>
                 <a:cs typeface="Calibri" pitchFamily="34" charset="-120"/>
               </a:rPr>
-              <a:t>3 checkboxes — pode aprovar parcialmente, integralmente, ou pedir ajustes.</a:t>
-            </a:r>
-            <a:endParaRPr lang="en-US" sz="1500" dirty="0"/>
-          </a:p>
-        </p:txBody>
-      </p:sp>
-      <p:sp>
-        <p:nvSpPr>
-          <p:cNvPr id="6" name="Shape 4"/>
-          <p:cNvSpPr/>
-          <p:nvPr/>
-        </p:nvSpPr>
-        <p:spPr>
-          <a:xfrm>
-            <a:off x="548640" y="1783080"/>
-            <a:ext cx="11064240" cy="868680"/>
-          </a:xfrm>
-          <a:prstGeom prst="roundRect">
-            <a:avLst>
-              <a:gd name="adj" fmla="val 10526"/>
-            </a:avLst>
-          </a:prstGeom>
-          <a:solidFill>
-            <a:srgbClr val="FFFFFF">
-              <a:alpha val="95000"/>
-            </a:srgbClr>
-          </a:solidFill>
-          <a:ln w="25400">
-            <a:solidFill>
-              <a:srgbClr val="22B07D"/>
-            </a:solidFill>
-            <a:prstDash val="solid"/>
-          </a:ln>
-        </p:spPr>
-      </p:sp>
-      <p:sp>
-        <p:nvSpPr>
-          <p:cNvPr id="7" name="Shape 5"/>
-          <p:cNvSpPr/>
-          <p:nvPr/>
-        </p:nvSpPr>
-        <p:spPr>
-          <a:xfrm>
-            <a:off x="822960" y="1965960"/>
-            <a:ext cx="502920" cy="502920"/>
-          </a:xfrm>
-          <a:prstGeom prst="roundRect">
-            <a:avLst>
-              <a:gd name="adj" fmla="val 9091"/>
-            </a:avLst>
-          </a:prstGeom>
-          <a:solidFill>
-            <a:srgbClr val="FFFFFF"/>
-          </a:solidFill>
-          <a:ln w="25400">
-            <a:solidFill>
-              <a:srgbClr val="22B07D"/>
-            </a:solidFill>
-            <a:prstDash val="solid"/>
-          </a:ln>
-        </p:spPr>
-      </p:sp>
-      <p:sp>
-        <p:nvSpPr>
-          <p:cNvPr id="8" name="Text 6"/>
-          <p:cNvSpPr/>
-          <p:nvPr/>
-        </p:nvSpPr>
-        <p:spPr>
-          <a:xfrm>
-            <a:off x="1417320" y="1874520"/>
-            <a:ext cx="457200" cy="685800"/>
-          </a:xfrm>
-          <a:prstGeom prst="rect">
-            <a:avLst/>
-          </a:prstGeom>
-          <a:noFill/>
-          <a:ln/>
-        </p:spPr>
-        <p:txBody>
-          <a:bodyPr wrap="square" lIns="0" tIns="0" rIns="0" bIns="0" rtlCol="0" anchor="ctr"/>
-          <a:lstStyle/>
-          <a:p>
-            <a:pPr algn="ctr" indent="0" marL="0">
-              <a:buNone/>
-            </a:pPr>
-            <a:r>
-              <a:rPr lang="en-US" sz="2800" b="1" dirty="0">
-                <a:solidFill>
-                  <a:srgbClr val="22B07D"/>
-                </a:solidFill>
-                <a:latin typeface="Cambria" pitchFamily="34" charset="0"/>
-                <a:ea typeface="Cambria" pitchFamily="34" charset="-122"/>
-                <a:cs typeface="Cambria" pitchFamily="34" charset="-120"/>
-              </a:rPr>
-              <a:t>A</a:t>
-            </a:r>
-            <a:endParaRPr lang="en-US" sz="2800" dirty="0"/>
-          </a:p>
-        </p:txBody>
-      </p:sp>
-      <p:sp>
-        <p:nvSpPr>
-          <p:cNvPr id="9" name="Text 7"/>
-          <p:cNvSpPr/>
-          <p:nvPr/>
-        </p:nvSpPr>
-        <p:spPr>
-          <a:xfrm>
-            <a:off x="1965960" y="1892808"/>
-            <a:ext cx="9509760" cy="365760"/>
-          </a:xfrm>
-          <a:prstGeom prst="rect">
-            <a:avLst/>
-          </a:prstGeom>
-          <a:noFill/>
-          <a:ln/>
-        </p:spPr>
-        <p:txBody>
-          <a:bodyPr wrap="square" lIns="0" tIns="0" rIns="0" bIns="0" rtlCol="0" anchor="ctr"/>
-          <a:lstStyle/>
-          <a:p>
-            <a:pPr indent="0" marL="0">
-              <a:buNone/>
-            </a:pPr>
-            <a:r>
-              <a:rPr lang="en-US" sz="1700" b="1" dirty="0">
-                <a:solidFill>
-                  <a:srgbClr val="FFFFFF"/>
-                </a:solidFill>
-                <a:latin typeface="Calibri" pitchFamily="34" charset="0"/>
-                <a:ea typeface="Calibri" pitchFamily="34" charset="-122"/>
-                <a:cs typeface="Calibri" pitchFamily="34" charset="-120"/>
-              </a:rPr>
-              <a:t>Refazer tutorial (Camada 1)</a:t>
-            </a:r>
-            <a:endParaRPr lang="en-US" sz="1700" dirty="0"/>
-          </a:p>
-        </p:txBody>
-      </p:sp>
-      <p:sp>
-        <p:nvSpPr>
-          <p:cNvPr id="10" name="Text 8"/>
-          <p:cNvSpPr/>
-          <p:nvPr/>
-        </p:nvSpPr>
-        <p:spPr>
-          <a:xfrm>
-            <a:off x="1965960" y="2240280"/>
-            <a:ext cx="9509760" cy="365760"/>
-          </a:xfrm>
-          <a:prstGeom prst="rect">
-            <a:avLst/>
-          </a:prstGeom>
-          <a:noFill/>
-          <a:ln/>
-        </p:spPr>
-        <p:txBody>
-          <a:bodyPr wrap="square" lIns="0" tIns="0" rIns="0" bIns="0" rtlCol="0" anchor="ctr"/>
-          <a:lstStyle/>
-          <a:p>
-            <a:pPr indent="0" marL="0">
-              <a:buNone/>
-            </a:pPr>
-            <a:r>
-              <a:rPr lang="en-US" sz="1200" dirty="0">
-                <a:solidFill>
-                  <a:srgbClr val="B9C2D6"/>
-                </a:solidFill>
-                <a:latin typeface="Calibri" pitchFamily="34" charset="0"/>
-                <a:ea typeface="Calibri" pitchFamily="34" charset="-122"/>
-                <a:cs typeface="Calibri" pitchFamily="34" charset="-120"/>
-              </a:rPr>
-              <a:t>~4 h dev · risco zero · faço esta semana</a:t>
-            </a:r>
-            <a:endParaRPr lang="en-US" sz="1200" dirty="0"/>
-          </a:p>
-        </p:txBody>
-      </p:sp>
-      <p:sp>
-        <p:nvSpPr>
-          <p:cNvPr id="11" name="Shape 9"/>
-          <p:cNvSpPr/>
-          <p:nvPr/>
-        </p:nvSpPr>
-        <p:spPr>
-          <a:xfrm>
-            <a:off x="548640" y="2743200"/>
-            <a:ext cx="11064240" cy="868680"/>
-          </a:xfrm>
-          <a:prstGeom prst="roundRect">
-            <a:avLst>
-              <a:gd name="adj" fmla="val 10526"/>
-            </a:avLst>
-          </a:prstGeom>
-          <a:solidFill>
-            <a:srgbClr val="FFFFFF">
-              <a:alpha val="95000"/>
-            </a:srgbClr>
-          </a:solidFill>
-          <a:ln w="25400">
-            <a:solidFill>
-              <a:srgbClr val="FF7639"/>
-            </a:solidFill>
-            <a:prstDash val="solid"/>
-          </a:ln>
-        </p:spPr>
-      </p:sp>
-      <p:sp>
-        <p:nvSpPr>
-          <p:cNvPr id="12" name="Shape 10"/>
-          <p:cNvSpPr/>
-          <p:nvPr/>
-        </p:nvSpPr>
-        <p:spPr>
-          <a:xfrm>
-            <a:off x="822960" y="2926080"/>
-            <a:ext cx="502920" cy="502920"/>
-          </a:xfrm>
-          <a:prstGeom prst="roundRect">
-            <a:avLst>
-              <a:gd name="adj" fmla="val 9091"/>
-            </a:avLst>
-          </a:prstGeom>
-          <a:solidFill>
-            <a:srgbClr val="FFFFFF"/>
-          </a:solidFill>
-          <a:ln w="25400">
-            <a:solidFill>
-              <a:srgbClr val="FF7639"/>
-            </a:solidFill>
-            <a:prstDash val="solid"/>
-          </a:ln>
-        </p:spPr>
-      </p:sp>
-      <p:sp>
-        <p:nvSpPr>
-          <p:cNvPr id="13" name="Text 11"/>
-          <p:cNvSpPr/>
-          <p:nvPr/>
-        </p:nvSpPr>
-        <p:spPr>
-          <a:xfrm>
-            <a:off x="1417320" y="2834640"/>
-            <a:ext cx="457200" cy="685800"/>
-          </a:xfrm>
-          <a:prstGeom prst="rect">
-            <a:avLst/>
-          </a:prstGeom>
-          <a:noFill/>
-          <a:ln/>
-        </p:spPr>
-        <p:txBody>
-          <a:bodyPr wrap="square" lIns="0" tIns="0" rIns="0" bIns="0" rtlCol="0" anchor="ctr"/>
-          <a:lstStyle/>
-          <a:p>
-            <a:pPr algn="ctr" indent="0" marL="0">
-              <a:buNone/>
-            </a:pPr>
-            <a:r>
-              <a:rPr lang="en-US" sz="2800" b="1" dirty="0">
-                <a:solidFill>
-                  <a:srgbClr val="FF7639"/>
-                </a:solidFill>
-                <a:latin typeface="Cambria" pitchFamily="34" charset="0"/>
-                <a:ea typeface="Cambria" pitchFamily="34" charset="-122"/>
-                <a:cs typeface="Cambria" pitchFamily="34" charset="-120"/>
-              </a:rPr>
-              <a:t>B</a:t>
-            </a:r>
-            <a:endParaRPr lang="en-US" sz="2800" dirty="0"/>
-          </a:p>
-        </p:txBody>
-      </p:sp>
-      <p:sp>
-        <p:nvSpPr>
-          <p:cNvPr id="14" name="Text 12"/>
-          <p:cNvSpPr/>
-          <p:nvPr/>
-        </p:nvSpPr>
-        <p:spPr>
-          <a:xfrm>
-            <a:off x="1965960" y="2852928"/>
-            <a:ext cx="9509760" cy="365760"/>
-          </a:xfrm>
-          <a:prstGeom prst="rect">
-            <a:avLst/>
-          </a:prstGeom>
-          <a:noFill/>
-          <a:ln/>
-        </p:spPr>
-        <p:txBody>
-          <a:bodyPr wrap="square" lIns="0" tIns="0" rIns="0" bIns="0" rtlCol="0" anchor="ctr"/>
-          <a:lstStyle/>
-          <a:p>
-            <a:pPr indent="0" marL="0">
-              <a:buNone/>
-            </a:pPr>
-            <a:r>
-              <a:rPr lang="en-US" sz="1700" b="1" dirty="0">
-                <a:solidFill>
-                  <a:srgbClr val="FFFFFF"/>
-                </a:solidFill>
-                <a:latin typeface="Calibri" pitchFamily="34" charset="0"/>
-                <a:ea typeface="Calibri" pitchFamily="34" charset="-122"/>
-                <a:cs typeface="Calibri" pitchFamily="34" charset="-120"/>
-              </a:rPr>
-              <a:t>Redesign do app (Camada 2)</a:t>
-            </a:r>
-            <a:endParaRPr lang="en-US" sz="1700" dirty="0"/>
-          </a:p>
-        </p:txBody>
-      </p:sp>
-      <p:sp>
-        <p:nvSpPr>
-          <p:cNvPr id="15" name="Text 13"/>
-          <p:cNvSpPr/>
-          <p:nvPr/>
-        </p:nvSpPr>
-        <p:spPr>
-          <a:xfrm>
-            <a:off x="1965960" y="3200400"/>
-            <a:ext cx="9509760" cy="365760"/>
-          </a:xfrm>
-          <a:prstGeom prst="rect">
-            <a:avLst/>
-          </a:prstGeom>
-          <a:noFill/>
-          <a:ln/>
-        </p:spPr>
-        <p:txBody>
-          <a:bodyPr wrap="square" lIns="0" tIns="0" rIns="0" bIns="0" rtlCol="0" anchor="ctr"/>
-          <a:lstStyle/>
-          <a:p>
-            <a:pPr indent="0" marL="0">
-              <a:buNone/>
-            </a:pPr>
-            <a:r>
-              <a:rPr lang="en-US" sz="1200" dirty="0">
-                <a:solidFill>
-                  <a:srgbClr val="B9C2D6"/>
-                </a:solidFill>
-                <a:latin typeface="Calibri" pitchFamily="34" charset="0"/>
-                <a:ea typeface="Calibri" pitchFamily="34" charset="-122"/>
-                <a:cs typeface="Calibri" pitchFamily="34" charset="-120"/>
-              </a:rPr>
-              <a:t>~3 dias dev · testar em homologação primeiro</a:t>
-            </a:r>
-            <a:endParaRPr lang="en-US" sz="1200" dirty="0"/>
-          </a:p>
-        </p:txBody>
-      </p:sp>
-      <p:sp>
-        <p:nvSpPr>
-          <p:cNvPr id="16" name="Shape 14"/>
-          <p:cNvSpPr/>
-          <p:nvPr/>
-        </p:nvSpPr>
-        <p:spPr>
-          <a:xfrm>
-            <a:off x="548640" y="3703320"/>
-            <a:ext cx="11064240" cy="868680"/>
-          </a:xfrm>
-          <a:prstGeom prst="roundRect">
-            <a:avLst>
-              <a:gd name="adj" fmla="val 10526"/>
-            </a:avLst>
-          </a:prstGeom>
-          <a:solidFill>
-            <a:srgbClr val="FFFFFF">
-              <a:alpha val="95000"/>
-            </a:srgbClr>
-          </a:solidFill>
-          <a:ln w="25400">
-            <a:solidFill>
-              <a:srgbClr val="1F51FE"/>
-            </a:solidFill>
-            <a:prstDash val="solid"/>
-          </a:ln>
-        </p:spPr>
-      </p:sp>
-      <p:sp>
-        <p:nvSpPr>
-          <p:cNvPr id="17" name="Shape 15"/>
-          <p:cNvSpPr/>
-          <p:nvPr/>
-        </p:nvSpPr>
-        <p:spPr>
-          <a:xfrm>
-            <a:off x="822960" y="3886200"/>
-            <a:ext cx="502920" cy="502920"/>
-          </a:xfrm>
-          <a:prstGeom prst="roundRect">
-            <a:avLst>
-              <a:gd name="adj" fmla="val 9091"/>
-            </a:avLst>
-          </a:prstGeom>
-          <a:solidFill>
-            <a:srgbClr val="FFFFFF"/>
-          </a:solidFill>
-          <a:ln w="25400">
-            <a:solidFill>
-              <a:srgbClr val="1F51FE"/>
-            </a:solidFill>
-            <a:prstDash val="solid"/>
-          </a:ln>
-        </p:spPr>
-      </p:sp>
-      <p:sp>
-        <p:nvSpPr>
-          <p:cNvPr id="18" name="Text 16"/>
-          <p:cNvSpPr/>
-          <p:nvPr/>
-        </p:nvSpPr>
-        <p:spPr>
-          <a:xfrm>
-            <a:off x="1417320" y="3794760"/>
-            <a:ext cx="457200" cy="685800"/>
-          </a:xfrm>
-          <a:prstGeom prst="rect">
-            <a:avLst/>
-          </a:prstGeom>
-          <a:noFill/>
-          <a:ln/>
-        </p:spPr>
-        <p:txBody>
-          <a:bodyPr wrap="square" lIns="0" tIns="0" rIns="0" bIns="0" rtlCol="0" anchor="ctr"/>
-          <a:lstStyle/>
-          <a:p>
-            <a:pPr algn="ctr" indent="0" marL="0">
-              <a:buNone/>
-            </a:pPr>
-            <a:r>
-              <a:rPr lang="en-US" sz="2800" b="1" dirty="0">
-                <a:solidFill>
-                  <a:srgbClr val="1F51FE"/>
-                </a:solidFill>
-                <a:latin typeface="Cambria" pitchFamily="34" charset="0"/>
-                <a:ea typeface="Cambria" pitchFamily="34" charset="-122"/>
-                <a:cs typeface="Cambria" pitchFamily="34" charset="-120"/>
-              </a:rPr>
-              <a:t>C</a:t>
-            </a:r>
-            <a:endParaRPr lang="en-US" sz="2800" dirty="0"/>
-          </a:p>
-        </p:txBody>
-      </p:sp>
-      <p:sp>
-        <p:nvSpPr>
-          <p:cNvPr id="19" name="Text 17"/>
-          <p:cNvSpPr/>
-          <p:nvPr/>
-        </p:nvSpPr>
-        <p:spPr>
-          <a:xfrm>
-            <a:off x="1965960" y="3813048"/>
-            <a:ext cx="9509760" cy="365760"/>
-          </a:xfrm>
-          <a:prstGeom prst="rect">
-            <a:avLst/>
-          </a:prstGeom>
-          <a:noFill/>
-          <a:ln/>
-        </p:spPr>
-        <p:txBody>
-          <a:bodyPr wrap="square" lIns="0" tIns="0" rIns="0" bIns="0" rtlCol="0" anchor="ctr"/>
-          <a:lstStyle/>
-          <a:p>
-            <a:pPr indent="0" marL="0">
-              <a:buNone/>
-            </a:pPr>
-            <a:r>
-              <a:rPr lang="en-US" sz="1700" b="1" dirty="0">
-                <a:solidFill>
-                  <a:srgbClr val="FFFFFF"/>
-                </a:solidFill>
-                <a:latin typeface="Calibri" pitchFamily="34" charset="0"/>
-                <a:ea typeface="Calibri" pitchFamily="34" charset="-122"/>
-                <a:cs typeface="Calibri" pitchFamily="34" charset="-120"/>
-              </a:rPr>
-              <a:t>Cartão A5 impresso (Camada 3)</a:t>
-            </a:r>
-            <a:endParaRPr lang="en-US" sz="1700" dirty="0"/>
-          </a:p>
-        </p:txBody>
-      </p:sp>
-      <p:sp>
-        <p:nvSpPr>
-          <p:cNvPr id="20" name="Text 18"/>
-          <p:cNvSpPr/>
-          <p:nvPr/>
-        </p:nvSpPr>
-        <p:spPr>
-          <a:xfrm>
-            <a:off x="1965960" y="4160520"/>
-            <a:ext cx="9509760" cy="365760"/>
-          </a:xfrm>
-          <a:prstGeom prst="rect">
-            <a:avLst/>
-          </a:prstGeom>
-          <a:noFill/>
-          <a:ln/>
-        </p:spPr>
-        <p:txBody>
-          <a:bodyPr wrap="square" lIns="0" tIns="0" rIns="0" bIns="0" rtlCol="0" anchor="ctr"/>
-          <a:lstStyle/>
-          <a:p>
-            <a:pPr indent="0" marL="0">
-              <a:buNone/>
-            </a:pPr>
-            <a:r>
-              <a:rPr lang="en-US" sz="1200" dirty="0">
-                <a:solidFill>
-                  <a:srgbClr val="B9C2D6"/>
-                </a:solidFill>
-                <a:latin typeface="Calibri" pitchFamily="34" charset="0"/>
-                <a:ea typeface="Calibri" pitchFamily="34" charset="-122"/>
-                <a:cs typeface="Calibri" pitchFamily="34" charset="-120"/>
-              </a:rPr>
-              <a:t>~R$ 5/veículo · uma ordem de impressão</a:t>
-            </a:r>
-            <a:endParaRPr lang="en-US" sz="1200" dirty="0"/>
-          </a:p>
-        </p:txBody>
-      </p:sp>
-      <p:sp>
-        <p:nvSpPr>
-          <p:cNvPr id="21" name="Shape 19"/>
-          <p:cNvSpPr/>
-          <p:nvPr/>
-        </p:nvSpPr>
-        <p:spPr>
-          <a:xfrm>
-            <a:off x="548640" y="4937760"/>
-            <a:ext cx="11064240" cy="1417320"/>
-          </a:xfrm>
-          <a:prstGeom prst="roundRect">
-            <a:avLst>
-              <a:gd name="adj" fmla="val 7742"/>
-            </a:avLst>
-          </a:prstGeom>
-          <a:solidFill>
-            <a:srgbClr val="1F2A55"/>
-          </a:solidFill>
-          <a:ln w="25400">
-            <a:solidFill>
-              <a:srgbClr val="FF7639"/>
-            </a:solidFill>
-            <a:prstDash val="solid"/>
-          </a:ln>
-        </p:spPr>
-      </p:sp>
-      <p:sp>
-        <p:nvSpPr>
-          <p:cNvPr id="22" name="Text 20"/>
-          <p:cNvSpPr/>
-          <p:nvPr/>
-        </p:nvSpPr>
-        <p:spPr>
-          <a:xfrm>
-            <a:off x="777240" y="5074920"/>
-            <a:ext cx="7315200" cy="365760"/>
-          </a:xfrm>
-          <a:prstGeom prst="rect">
-            <a:avLst/>
-          </a:prstGeom>
-          <a:noFill/>
-          <a:ln/>
-        </p:spPr>
-        <p:txBody>
-          <a:bodyPr wrap="square" lIns="0" tIns="0" rIns="0" bIns="0" rtlCol="0" anchor="ctr"/>
-          <a:lstStyle/>
-          <a:p>
-            <a:pPr indent="0" marL="0">
-              <a:buNone/>
-            </a:pPr>
-            <a:r>
-              <a:rPr lang="en-US" sz="1200" b="1" spc="400" kern="0" dirty="0">
-                <a:solidFill>
-                  <a:srgbClr val="FF7639"/>
-                </a:solidFill>
-                <a:latin typeface="Calibri" pitchFamily="34" charset="0"/>
-                <a:ea typeface="Calibri" pitchFamily="34" charset="-122"/>
-                <a:cs typeface="Calibri" pitchFamily="34" charset="-120"/>
-              </a:rPr>
-              <a:t>KPI sugerido para medir:</a:t>
-            </a:r>
-            <a:endParaRPr lang="en-US" sz="1200" dirty="0"/>
-          </a:p>
-        </p:txBody>
-      </p:sp>
-      <p:sp>
-        <p:nvSpPr>
-          <p:cNvPr id="23" name="Text 21"/>
-          <p:cNvSpPr/>
-          <p:nvPr/>
-        </p:nvSpPr>
-        <p:spPr>
-          <a:xfrm>
-            <a:off x="777240" y="5440680"/>
-            <a:ext cx="7315200" cy="502920"/>
-          </a:xfrm>
-          <a:prstGeom prst="rect">
-            <a:avLst/>
-          </a:prstGeom>
-          <a:noFill/>
-          <a:ln/>
-        </p:spPr>
-        <p:txBody>
-          <a:bodyPr wrap="square" lIns="0" tIns="0" rIns="0" bIns="0" rtlCol="0" anchor="ctr"/>
-          <a:lstStyle/>
-          <a:p>
-            <a:pPr indent="0" marL="0">
-              <a:buNone/>
-            </a:pPr>
-            <a:r>
-              <a:rPr lang="en-US" sz="2100" b="1" dirty="0">
-                <a:solidFill>
-                  <a:srgbClr val="FFFFFF"/>
-                </a:solidFill>
-                <a:latin typeface="Cambria" pitchFamily="34" charset="0"/>
-                <a:ea typeface="Cambria" pitchFamily="34" charset="-122"/>
-                <a:cs typeface="Cambria" pitchFamily="34" charset="-120"/>
-              </a:rPr>
-              <a:t>% de turnos com encerramento no mesmo dia</a:t>
-            </a:r>
-            <a:endParaRPr lang="en-US" sz="2100" dirty="0"/>
-          </a:p>
-        </p:txBody>
-      </p:sp>
-      <p:sp>
-        <p:nvSpPr>
-          <p:cNvPr id="24" name="Text 22"/>
-          <p:cNvSpPr/>
-          <p:nvPr/>
-        </p:nvSpPr>
-        <p:spPr>
-          <a:xfrm>
-            <a:off x="777240" y="5943600"/>
-            <a:ext cx="7315200" cy="365760"/>
-          </a:xfrm>
-          <a:prstGeom prst="rect">
-            <a:avLst/>
-          </a:prstGeom>
-          <a:noFill/>
-          <a:ln/>
-        </p:spPr>
-        <p:txBody>
-          <a:bodyPr wrap="square" lIns="0" tIns="0" rIns="0" bIns="0" rtlCol="0" anchor="ctr"/>
-          <a:lstStyle/>
-          <a:p>
-            <a:pPr indent="0" marL="0">
-              <a:buNone/>
-            </a:pPr>
-            <a:r>
-              <a:rPr lang="en-US" sz="1300" dirty="0">
-                <a:solidFill>
-                  <a:srgbClr val="B9C2D6"/>
-                </a:solidFill>
-                <a:latin typeface="Calibri" pitchFamily="34" charset="0"/>
-                <a:ea typeface="Calibri" pitchFamily="34" charset="-122"/>
-                <a:cs typeface="Calibri" pitchFamily="34" charset="-120"/>
-              </a:rPr>
-              <a:t>Hoje (estimado): &lt; 60 %  →  Meta em 4 semanas: ≥ 90 %</a:t>
+              <a:t>R$ 5 × frota (uma vez)</a:t>
             </a:r>
             <a:endParaRPr lang="en-US" sz="1300" dirty="0"/>
-          </a:p>
-        </p:txBody>
-      </p:sp>
-      <p:sp>
-        <p:nvSpPr>
-          <p:cNvPr id="25" name="Text 23"/>
-          <p:cNvSpPr/>
-          <p:nvPr/>
-        </p:nvSpPr>
-        <p:spPr>
-          <a:xfrm>
-            <a:off x="8686800" y="4983480"/>
-            <a:ext cx="2743200" cy="1371600"/>
-          </a:xfrm>
-          <a:prstGeom prst="rect">
-            <a:avLst/>
-          </a:prstGeom>
-          <a:noFill/>
-          <a:ln/>
-        </p:spPr>
-        <p:txBody>
-          <a:bodyPr wrap="square" lIns="0" tIns="0" rIns="0" bIns="0" rtlCol="0" anchor="ctr"/>
-          <a:lstStyle/>
-          <a:p>
-            <a:pPr algn="ctr" indent="0" marL="0">
-              <a:buNone/>
-            </a:pPr>
-            <a:r>
-              <a:rPr lang="en-US" sz="8400" b="1" dirty="0">
-                <a:solidFill>
-                  <a:srgbClr val="FF7639"/>
-                </a:solidFill>
-                <a:latin typeface="Cambria" pitchFamily="34" charset="0"/>
-                <a:ea typeface="Cambria" pitchFamily="34" charset="-122"/>
-                <a:cs typeface="Cambria" pitchFamily="34" charset="-120"/>
-              </a:rPr>
-              <a:t>90%</a:t>
-            </a:r>
-            <a:endParaRPr lang="en-US" sz="8400" dirty="0"/>
-          </a:p>
-        </p:txBody>
-      </p:sp>
-      <p:sp>
-        <p:nvSpPr>
-          <p:cNvPr id="26" name="Text 24"/>
-          <p:cNvSpPr/>
-          <p:nvPr/>
-        </p:nvSpPr>
-        <p:spPr>
-          <a:xfrm>
-            <a:off x="548640" y="6492240"/>
-            <a:ext cx="11064240" cy="274320"/>
-          </a:xfrm>
-          <a:prstGeom prst="rect">
-            <a:avLst/>
-          </a:prstGeom>
-          <a:noFill/>
-          <a:ln/>
-        </p:spPr>
-        <p:txBody>
-          <a:bodyPr wrap="square" lIns="0" tIns="0" rIns="0" bIns="0" rtlCol="0" anchor="ctr"/>
-          <a:lstStyle/>
-          <a:p>
-            <a:pPr algn="ctr" indent="0" marL="0">
-              <a:buNone/>
-            </a:pPr>
-            <a:r>
-              <a:rPr lang="en-US" sz="1100" dirty="0">
-                <a:solidFill>
-                  <a:srgbClr val="8A93A6"/>
-                </a:solidFill>
-                <a:latin typeface="Calibri" pitchFamily="34" charset="0"/>
-                <a:ea typeface="Calibri" pitchFamily="34" charset="-122"/>
-                <a:cs typeface="Calibri" pitchFamily="34" charset="-120"/>
-              </a:rPr>
-              <a:t>Samuel Ferreira de Melo   ·   </a:t>
-            </a:r>
-            <a:pPr algn="ctr" indent="0" marL="0">
-              <a:buNone/>
-            </a:pPr>
-            <a:r>
-              <a:rPr lang="en-US" sz="1100" dirty="0">
-                <a:solidFill>
-                  <a:srgbClr val="FFFFFF"/>
-                </a:solidFill>
-                <a:latin typeface="Calibri" pitchFamily="34" charset="0"/>
-                <a:ea typeface="Calibri" pitchFamily="34" charset="-122"/>
-                <a:cs typeface="Calibri" pitchFamily="34" charset="-120"/>
-              </a:rPr>
-              <a:t>samuel.melo@engetecnica.com.br</a:t>
-            </a:r>
-            <a:endParaRPr lang="en-US" sz="1100" dirty="0"/>
           </a:p>
         </p:txBody>
       </p:sp>

</xml_diff>